<commit_message>
docs: correct lesson 12 evaluation deck semantics
</commit_message>
<xml_diff>
--- a/decks/12-evaluating-agentic-systems.pptx
+++ b/decks/12-evaluating-agentic-systems.pptx
@@ -2,21 +2,21 @@
 <file path=ppt/presentation.xml><?xml version="1.0" encoding="utf-8"?>
 <p:presentation xmlns:p="http://schemas.openxmlformats.org/presentationml/2006/main">
   <p:sldMasterIdLst>
-    <p:sldMasterId xmlns:r="http://schemas.openxmlformats.org/officeDocument/2006/relationships" id="2147483648" r:id="Rc634d8a1465940d9"/>
+    <p:sldMasterId xmlns:r="http://schemas.openxmlformats.org/officeDocument/2006/relationships" id="2147483648" r:id="R59a76237e79d4563"/>
   </p:sldMasterIdLst>
   <p:notesMasterIdLst>
-    <p:notesMasterId xmlns:r="http://schemas.openxmlformats.org/officeDocument/2006/relationships" r:id="R6884eca8c3a54e6c"/>
+    <p:notesMasterId xmlns:r="http://schemas.openxmlformats.org/officeDocument/2006/relationships" r:id="Rdc09e47772704cd8"/>
   </p:notesMasterIdLst>
   <p:sldIdLst>
-    <p:sldId xmlns:r="http://schemas.openxmlformats.org/officeDocument/2006/relationships" id="256" r:id="R1b84239b5f154bba"/>
-    <p:sldId xmlns:r="http://schemas.openxmlformats.org/officeDocument/2006/relationships" id="257" r:id="Ra095a4c1bf234c05"/>
-    <p:sldId xmlns:r="http://schemas.openxmlformats.org/officeDocument/2006/relationships" id="258" r:id="R3cb3857268bc46b6"/>
-    <p:sldId xmlns:r="http://schemas.openxmlformats.org/officeDocument/2006/relationships" id="259" r:id="R6487e87bb27d437a"/>
-    <p:sldId xmlns:r="http://schemas.openxmlformats.org/officeDocument/2006/relationships" id="260" r:id="Rcadd20a45bf94bdf"/>
-    <p:sldId xmlns:r="http://schemas.openxmlformats.org/officeDocument/2006/relationships" id="261" r:id="R52633a79d86e4c73"/>
-    <p:sldId xmlns:r="http://schemas.openxmlformats.org/officeDocument/2006/relationships" id="262" r:id="R08418420aacd4a33"/>
-    <p:sldId xmlns:r="http://schemas.openxmlformats.org/officeDocument/2006/relationships" id="263" r:id="R7e13d98d30e345ed"/>
-    <p:sldId xmlns:r="http://schemas.openxmlformats.org/officeDocument/2006/relationships" id="264" r:id="R5ca61f53fbb8492e"/>
+    <p:sldId xmlns:r="http://schemas.openxmlformats.org/officeDocument/2006/relationships" id="256" r:id="Re22afbb562d74bf4"/>
+    <p:sldId xmlns:r="http://schemas.openxmlformats.org/officeDocument/2006/relationships" id="257" r:id="Rb10cc6cd271f4c40"/>
+    <p:sldId xmlns:r="http://schemas.openxmlformats.org/officeDocument/2006/relationships" id="258" r:id="R0cfbf952c62f40d3"/>
+    <p:sldId xmlns:r="http://schemas.openxmlformats.org/officeDocument/2006/relationships" id="259" r:id="R81cfa46cac804568"/>
+    <p:sldId xmlns:r="http://schemas.openxmlformats.org/officeDocument/2006/relationships" id="260" r:id="R99edcc5828a341c4"/>
+    <p:sldId xmlns:r="http://schemas.openxmlformats.org/officeDocument/2006/relationships" id="261" r:id="Re3c7d6a4ef7847c1"/>
+    <p:sldId xmlns:r="http://schemas.openxmlformats.org/officeDocument/2006/relationships" id="262" r:id="R7ab354306ae54043"/>
+    <p:sldId xmlns:r="http://schemas.openxmlformats.org/officeDocument/2006/relationships" id="263" r:id="R8af884050dba4547"/>
+    <p:sldId xmlns:r="http://schemas.openxmlformats.org/officeDocument/2006/relationships" id="264" r:id="Rdfbbda0e45414224"/>
   </p:sldIdLst>
   <p:sldSz cx="15240000" cy="8572500"/>
   <p:notesSz cx="6858000" cy="9144000"/>
@@ -1338,7 +1338,7 @@
   </p:cSld>
   <p:clrMap bg1="lt1" tx1="dk1" bg2="lt2" tx2="dk2" accent1="accent1" accent2="accent2" accent3="accent3" accent4="accent4" accent5="accent5" accent6="accent6" hlink="hlink" folHlink="folHlink"/>
   <p:sldLayoutIdLst>
-    <p:sldLayoutId xmlns:r="http://schemas.openxmlformats.org/officeDocument/2006/relationships" id="2147483649" r:id="R87ff9d1615e547ad"/>
+    <p:sldLayoutId xmlns:r="http://schemas.openxmlformats.org/officeDocument/2006/relationships" id="2147483649" r:id="Ree5c2b79982f4a36"/>
   </p:sldLayoutIdLst>
   <p:txStyles>
     <p:titleStyle>
@@ -3491,7 +3491,7 @@
             </a:avLst>
           </a:prstGeom>
           <a:solidFill xmlns:a="http://schemas.openxmlformats.org/drawingml/2006/main">
-            <a:srgbClr val="2E8B57"/>
+            <a:srgbClr val="F07D00"/>
           </a:solidFill>
           <a:ln xmlns:a="http://schemas.openxmlformats.org/drawingml/2006/main" w="9525">
             <a:solidFill>
@@ -3597,24 +3597,24 @@
           </a:bodyPr>
           <a:lstStyle xmlns:a="http://schemas.openxmlformats.org/drawingml/2006/main"/>
           <a:p xmlns:a="http://schemas.openxmlformats.org/drawingml/2006/main">
-            <a:pPr algn="r">
+            <a:pPr algn="ctr">
               <a:lnSpc>
                 <a:spcPct val="100000"/>
               </a:lnSpc>
               <a:buNone/>
               <a:defRPr sz="1350" b="1">
                 <a:solidFill>
-                  <a:srgbClr val="2E8B57"/>
-                </a:solidFill>
-                <a:latin typeface="Calibri"/>
-                <a:ea typeface="Calibri"/>
-                <a:cs typeface="Calibri"/>
-              </a:defRPr>
-            </a:pPr>
-            <a:r>
-              <a:rPr sz="1800" b="1">
-                <a:solidFill>
-                  <a:srgbClr val="2E8B57"/>
+                  <a:srgbClr val="F07D00"/>
+                </a:solidFill>
+                <a:latin typeface="Calibri"/>
+                <a:ea typeface="Calibri"/>
+                <a:cs typeface="Calibri"/>
+              </a:defRPr>
+            </a:pPr>
+            <a:r>
+              <a:rPr sz="1350" b="1">
+                <a:solidFill>
+                  <a:srgbClr val="F07D00"/>
                 </a:solidFill>
                 <a:latin typeface="Calibri"/>
                 <a:ea typeface="Calibri"/>
@@ -5078,7 +5078,7 @@
                 <a:ea typeface="Calibri"/>
                 <a:cs typeface="Calibri"/>
               </a:rPr>
-              <a:t>CASE ID</a:t>
+              <a:t>VERSION KEYS</a:t>
             </a:r>
           </a:p>
         </p:txBody>
@@ -6102,7 +6102,7 @@
                 <a:ea typeface="Calibri"/>
                 <a:cs typeface="Calibri"/>
               </a:rPr>
-              <a:t>max_tool_calls: 6</a:t>
+              <a:t>max_tool_calls: 5</a:t>
             </a:r>
           </a:p>
         </p:txBody>
@@ -6391,7 +6391,7 @@
                 <a:ea typeface="Calibri"/>
                 <a:cs typeface="Calibri"/>
               </a:rPr>
-              <a:t>Fix the mission, expected calls, evidence gate, and budget.</a:t>
+              <a:t>dataset_version: agent-cases-v1  |  case_id: reference_completed  |  max_tool_calls: 5</a:t>
             </a:r>
           </a:p>
         </p:txBody>
@@ -8374,57 +8374,22 @@
       </p:sp>
       <p:sp>
         <p:nvSpPr>
-          <p:cNvPr id="3" name="ingestion-1">
-            <a:extLst xmlns:a="http://schemas.openxmlformats.org/drawingml/2006/main">
-              <a:ext uri="{FF2B5EF4-FFF2-40B4-BE49-F238E27FC236}">
-                <a16:creationId xmlns:a16="http://schemas.microsoft.com/office/drawing/2014/main" id="{EF5CEA91-0836-4E99-95C1-43A271A11FFF}"/>
-              </a:ext>
-            </a:extLst>
-          </p:cNvPr>
-          <p:cNvSpPr>
-            <a:spLocks xmlns:a="http://schemas.openxmlformats.org/drawingml/2006/main" noGrp="1"/>
-          </p:cNvSpPr>
-          <p:nvPr/>
-        </p:nvSpPr>
-        <p:spPr>
-          <a:xfrm xmlns:a="http://schemas.openxmlformats.org/drawingml/2006/main">
-            <a:off x="990600" y="3086100"/>
-            <a:ext cx="2247900" cy="2266950"/>
-          </a:xfrm>
-          <a:prstGeom xmlns:a="http://schemas.openxmlformats.org/drawingml/2006/main" prst="roundRect">
-            <a:avLst>
-              <a:gd name="adj" fmla="val 5085"/>
-            </a:avLst>
-          </a:prstGeom>
-          <a:solidFill xmlns:a="http://schemas.openxmlformats.org/drawingml/2006/main">
-            <a:srgbClr val="FFFFFF"/>
-          </a:solidFill>
-          <a:ln xmlns:a="http://schemas.openxmlformats.org/drawingml/2006/main" w="9525">
-            <a:solidFill>
-              <a:srgbClr val="E4E7E9"/>
-            </a:solidFill>
-            <a:prstDash val="solid"/>
-          </a:ln>
-        </p:spPr>
-      </p:sp>
-      <p:sp>
-        <p:nvSpPr>
-          <p:cNvPr id="4" name="">
-            <a:extLst xmlns:a="http://schemas.openxmlformats.org/drawingml/2006/main">
-              <a:ext uri="{FF2B5EF4-FFF2-40B4-BE49-F238E27FC236}">
-                <a16:creationId xmlns:a16="http://schemas.microsoft.com/office/drawing/2014/main" id="{4A163ADC-FDBA-49AB-AB53-62FA29104479}"/>
-              </a:ext>
-            </a:extLst>
-          </p:cNvPr>
-          <p:cNvSpPr>
-            <a:spLocks xmlns:a="http://schemas.openxmlformats.org/drawingml/2006/main" noGrp="1"/>
-          </p:cNvSpPr>
-          <p:nvPr/>
-        </p:nvSpPr>
-        <p:spPr>
-          <a:xfrm xmlns:a="http://schemas.openxmlformats.org/drawingml/2006/main">
-            <a:off x="1181100" y="3295650"/>
-            <a:ext cx="514350" cy="285750"/>
+          <p:cNvPr id="27" name="">
+            <a:extLst xmlns:a="http://schemas.openxmlformats.org/drawingml/2006/main">
+              <a:ext uri="{FF2B5EF4-FFF2-40B4-BE49-F238E27FC236}">
+                <a16:creationId xmlns:a16="http://schemas.microsoft.com/office/drawing/2014/main" id="{79128475-820B-447C-A724-7D8A31328FFE}"/>
+              </a:ext>
+            </a:extLst>
+          </p:cNvPr>
+          <p:cNvSpPr>
+            <a:spLocks xmlns:a="http://schemas.openxmlformats.org/drawingml/2006/main" noGrp="1"/>
+          </p:cNvSpPr>
+          <p:nvPr/>
+        </p:nvSpPr>
+        <p:spPr>
+          <a:xfrm xmlns:a="http://schemas.openxmlformats.org/drawingml/2006/main">
+            <a:off x="2381250" y="6210300"/>
+            <a:ext cx="10477500" cy="457200"/>
           </a:xfrm>
           <a:prstGeom xmlns:a="http://schemas.openxmlformats.org/drawingml/2006/main" prst="rect">
             <a:avLst/>
@@ -8437,56 +8402,56 @@
         </p:spPr>
         <p:txBody>
           <a:bodyPr xmlns:a="http://schemas.openxmlformats.org/drawingml/2006/main" wrap="square" lIns="0" tIns="0" rIns="0" bIns="0" anchor="ctr">
-            <a:noAutofit/>
+            <a:normAutofit fontScale="100000"/>
           </a:bodyPr>
           <a:lstStyle xmlns:a="http://schemas.openxmlformats.org/drawingml/2006/main"/>
           <a:p xmlns:a="http://schemas.openxmlformats.org/drawingml/2006/main">
-            <a:pPr algn="l">
+            <a:pPr algn="ctr">
               <a:lnSpc>
                 <a:spcPct val="100000"/>
               </a:lnSpc>
               <a:buNone/>
-              <a:defRPr sz="1350" b="1">
-                <a:solidFill>
-                  <a:srgbClr val="00A2EB"/>
-                </a:solidFill>
-                <a:latin typeface="Calibri"/>
-                <a:ea typeface="Calibri"/>
-                <a:cs typeface="Calibri"/>
-              </a:defRPr>
-            </a:pPr>
-            <a:r>
-              <a:rPr sz="1800" b="1">
-                <a:solidFill>
-                  <a:srgbClr val="00A2EB"/>
-                </a:solidFill>
-                <a:latin typeface="Calibri"/>
-                <a:ea typeface="Calibri"/>
-                <a:cs typeface="Calibri"/>
-              </a:rPr>
-              <a:t>01</a:t>
-            </a:r>
-          </a:p>
-        </p:txBody>
-      </p:sp>
-      <p:sp>
-        <p:nvSpPr>
-          <p:cNvPr id="5" name="">
-            <a:extLst xmlns:a="http://schemas.openxmlformats.org/drawingml/2006/main">
-              <a:ext uri="{FF2B5EF4-FFF2-40B4-BE49-F238E27FC236}">
-                <a16:creationId xmlns:a16="http://schemas.microsoft.com/office/drawing/2014/main" id="{26D1AD73-F995-4369-A266-8FA41354CE3D}"/>
-              </a:ext>
-            </a:extLst>
-          </p:cNvPr>
-          <p:cNvSpPr>
-            <a:spLocks xmlns:a="http://schemas.openxmlformats.org/drawingml/2006/main" noGrp="1"/>
-          </p:cNvSpPr>
-          <p:nvPr/>
-        </p:nvSpPr>
-        <p:spPr>
-          <a:xfrm xmlns:a="http://schemas.openxmlformats.org/drawingml/2006/main">
-            <a:off x="1104900" y="3752850"/>
-            <a:ext cx="2019300" cy="685800"/>
+              <a:defRPr sz="2100" b="1">
+                <a:solidFill>
+                  <a:srgbClr val="051C2A"/>
+                </a:solidFill>
+                <a:latin typeface="Calibri"/>
+                <a:ea typeface="Calibri"/>
+                <a:cs typeface="Calibri"/>
+              </a:defRPr>
+            </a:pPr>
+            <a:r>
+              <a:rPr sz="2100" b="1">
+                <a:solidFill>
+                  <a:srgbClr val="051C2A"/>
+                </a:solidFill>
+                <a:latin typeface="Calibri"/>
+                <a:ea typeface="Calibri"/>
+                <a:cs typeface="Calibri"/>
+              </a:rPr>
+              <a:t>Post-error success must clear the evidence gate before report.</a:t>
+            </a:r>
+          </a:p>
+        </p:txBody>
+      </p:sp>
+      <p:sp>
+        <p:nvSpPr>
+          <p:cNvPr id="28" name="">
+            <a:extLst xmlns:a="http://schemas.openxmlformats.org/drawingml/2006/main">
+              <a:ext uri="{FF2B5EF4-FFF2-40B4-BE49-F238E27FC236}">
+                <a16:creationId xmlns:a16="http://schemas.microsoft.com/office/drawing/2014/main" id="{685F2AAD-81FC-436A-88F7-89F49C9F1671}"/>
+              </a:ext>
+            </a:extLst>
+          </p:cNvPr>
+          <p:cNvSpPr>
+            <a:spLocks xmlns:a="http://schemas.openxmlformats.org/drawingml/2006/main" noGrp="1"/>
+          </p:cNvSpPr>
+          <p:nvPr/>
+        </p:nvSpPr>
+        <p:spPr>
+          <a:xfrm xmlns:a="http://schemas.openxmlformats.org/drawingml/2006/main">
+            <a:off x="1885950" y="6838950"/>
+            <a:ext cx="4476750" cy="323850"/>
           </a:xfrm>
           <a:prstGeom xmlns:a="http://schemas.openxmlformats.org/drawingml/2006/main" prst="rect">
             <a:avLst/>
@@ -8503,52 +8468,180 @@
           </a:bodyPr>
           <a:lstStyle xmlns:a="http://schemas.openxmlformats.org/drawingml/2006/main"/>
           <a:p xmlns:a="http://schemas.openxmlformats.org/drawingml/2006/main">
-            <a:pPr algn="l">
+            <a:pPr algn="ctr">
               <a:lnSpc>
                 <a:spcPct val="100000"/>
               </a:lnSpc>
               <a:buNone/>
-              <a:defRPr sz="1950" b="1">
-                <a:solidFill>
-                  <a:srgbClr val="051C2A"/>
-                </a:solidFill>
-                <a:latin typeface="Calibri"/>
-                <a:ea typeface="Calibri"/>
-                <a:cs typeface="Calibri"/>
-              </a:defRPr>
-            </a:pPr>
-            <a:r>
-              <a:rPr sz="1950" b="1">
-                <a:solidFill>
-                  <a:srgbClr val="051C2A"/>
-                </a:solidFill>
-                <a:latin typeface="Calibri"/>
-                <a:ea typeface="Calibri"/>
-                <a:cs typeface="Calibri"/>
-              </a:rPr>
-              <a:t>PLAN</a:t>
-            </a:r>
-          </a:p>
-        </p:txBody>
-      </p:sp>
-      <p:sp>
-        <p:nvSpPr>
-          <p:cNvPr id="6" name="">
-            <a:extLst xmlns:a="http://schemas.openxmlformats.org/drawingml/2006/main">
-              <a:ext uri="{FF2B5EF4-FFF2-40B4-BE49-F238E27FC236}">
-                <a16:creationId xmlns:a16="http://schemas.microsoft.com/office/drawing/2014/main" id="{4CA7F72B-07B6-4BF4-A3F9-5860F8AC7245}"/>
-              </a:ext>
-            </a:extLst>
-          </p:cNvPr>
-          <p:cNvSpPr>
-            <a:spLocks xmlns:a="http://schemas.openxmlformats.org/drawingml/2006/main" noGrp="1"/>
-          </p:cNvSpPr>
-          <p:nvPr/>
-        </p:nvSpPr>
-        <p:spPr>
-          <a:xfrm xmlns:a="http://schemas.openxmlformats.org/drawingml/2006/main">
-            <a:off x="1181100" y="4610100"/>
-            <a:ext cx="1866900" cy="514350"/>
+              <a:defRPr sz="1500" b="0">
+                <a:solidFill>
+                  <a:srgbClr val="64748B"/>
+                </a:solidFill>
+                <a:latin typeface="Calibri"/>
+                <a:ea typeface="Calibri"/>
+                <a:cs typeface="Calibri"/>
+              </a:defRPr>
+            </a:pPr>
+            <a:r>
+              <a:rPr sz="1500" b="0">
+                <a:solidFill>
+                  <a:srgbClr val="64748B"/>
+                </a:solidFill>
+                <a:latin typeface="Calibri"/>
+                <a:ea typeface="Calibri"/>
+                <a:cs typeface="Calibri"/>
+              </a:rPr>
+              <a:t>typed error retained</a:t>
+            </a:r>
+          </a:p>
+        </p:txBody>
+      </p:sp>
+      <p:sp>
+        <p:nvSpPr>
+          <p:cNvPr id="29" name="">
+            <a:extLst xmlns:a="http://schemas.openxmlformats.org/drawingml/2006/main">
+              <a:ext uri="{FF2B5EF4-FFF2-40B4-BE49-F238E27FC236}">
+                <a16:creationId xmlns:a16="http://schemas.microsoft.com/office/drawing/2014/main" id="{CDE04AD7-6CBE-4792-B549-765578FB3E1E}"/>
+              </a:ext>
+            </a:extLst>
+          </p:cNvPr>
+          <p:cNvSpPr>
+            <a:spLocks xmlns:a="http://schemas.openxmlformats.org/drawingml/2006/main" noGrp="1"/>
+          </p:cNvSpPr>
+          <p:nvPr/>
+        </p:nvSpPr>
+        <p:spPr>
+          <a:xfrm xmlns:a="http://schemas.openxmlformats.org/drawingml/2006/main">
+            <a:off x="8801100" y="6838950"/>
+            <a:ext cx="4762500" cy="323850"/>
+          </a:xfrm>
+          <a:prstGeom xmlns:a="http://schemas.openxmlformats.org/drawingml/2006/main" prst="rect">
+            <a:avLst/>
+          </a:prstGeom>
+          <a:noFill xmlns:a="http://schemas.openxmlformats.org/drawingml/2006/main"/>
+          <a:ln xmlns:a="http://schemas.openxmlformats.org/drawingml/2006/main" w="0">
+            <a:noFill/>
+            <a:prstDash val="solid"/>
+          </a:ln>
+        </p:spPr>
+        <p:txBody>
+          <a:bodyPr xmlns:a="http://schemas.openxmlformats.org/drawingml/2006/main" wrap="square" lIns="0" tIns="0" rIns="0" bIns="0" anchor="ctr">
+            <a:normAutofit fontScale="100000"/>
+          </a:bodyPr>
+          <a:lstStyle xmlns:a="http://schemas.openxmlformats.org/drawingml/2006/main"/>
+          <a:p xmlns:a="http://schemas.openxmlformats.org/drawingml/2006/main">
+            <a:pPr algn="ctr">
+              <a:lnSpc>
+                <a:spcPct val="100000"/>
+              </a:lnSpc>
+              <a:buNone/>
+              <a:defRPr sz="1500" b="0">
+                <a:solidFill>
+                  <a:srgbClr val="64748B"/>
+                </a:solidFill>
+                <a:latin typeface="Calibri"/>
+                <a:ea typeface="Calibri"/>
+                <a:cs typeface="Calibri"/>
+              </a:defRPr>
+            </a:pPr>
+            <a:r>
+              <a:rPr sz="1500" b="0">
+                <a:solidFill>
+                  <a:srgbClr val="64748B"/>
+                </a:solidFill>
+                <a:latin typeface="Calibri"/>
+                <a:ea typeface="Calibri"/>
+                <a:cs typeface="Calibri"/>
+              </a:rPr>
+              <a:t>bounded recovery succeeds</a:t>
+            </a:r>
+          </a:p>
+        </p:txBody>
+      </p:sp>
+      <p:sp>
+        <p:nvSpPr>
+          <p:cNvPr id="30" name="">
+            <a:extLst xmlns:a="http://schemas.openxmlformats.org/drawingml/2006/main">
+              <a:ext uri="{FF2B5EF4-FFF2-40B4-BE49-F238E27FC236}">
+                <a16:creationId xmlns:a16="http://schemas.microsoft.com/office/drawing/2014/main" id="{28CBA7AE-993C-4F84-A696-8D1323AC4E80}"/>
+              </a:ext>
+            </a:extLst>
+          </p:cNvPr>
+          <p:cNvSpPr>
+            <a:spLocks xmlns:a="http://schemas.openxmlformats.org/drawingml/2006/main" noGrp="1"/>
+          </p:cNvSpPr>
+          <p:nvPr/>
+        </p:nvSpPr>
+        <p:spPr>
+          <a:xfrm xmlns:a="http://schemas.openxmlformats.org/drawingml/2006/main">
+            <a:off x="857250" y="7896225"/>
+            <a:ext cx="13525500" cy="28575"/>
+          </a:xfrm>
+          <a:prstGeom xmlns:a="http://schemas.openxmlformats.org/drawingml/2006/main" prst="rect">
+            <a:avLst/>
+          </a:prstGeom>
+          <a:solidFill xmlns:a="http://schemas.openxmlformats.org/drawingml/2006/main">
+            <a:srgbClr val="E4E7E9"/>
+          </a:solidFill>
+          <a:ln xmlns:a="http://schemas.openxmlformats.org/drawingml/2006/main" w="0">
+            <a:solidFill>
+              <a:srgbClr val="E4E7E9"/>
+            </a:solidFill>
+            <a:prstDash val="solid"/>
+          </a:ln>
+        </p:spPr>
+      </p:sp>
+      <p:sp>
+        <p:nvSpPr>
+          <p:cNvPr id="31" name="">
+            <a:extLst xmlns:a="http://schemas.openxmlformats.org/drawingml/2006/main">
+              <a:ext uri="{FF2B5EF4-FFF2-40B4-BE49-F238E27FC236}">
+                <a16:creationId xmlns:a16="http://schemas.microsoft.com/office/drawing/2014/main" id="{DE97BF4D-EDBC-4480-A82B-512A72221950}"/>
+              </a:ext>
+            </a:extLst>
+          </p:cNvPr>
+          <p:cNvSpPr>
+            <a:spLocks xmlns:a="http://schemas.openxmlformats.org/drawingml/2006/main" noGrp="1"/>
+          </p:cNvSpPr>
+          <p:nvPr/>
+        </p:nvSpPr>
+        <p:spPr>
+          <a:xfrm xmlns:a="http://schemas.openxmlformats.org/drawingml/2006/main">
+            <a:off x="857250" y="7896225"/>
+            <a:ext cx="8001000" cy="38100"/>
+          </a:xfrm>
+          <a:prstGeom xmlns:a="http://schemas.openxmlformats.org/drawingml/2006/main" prst="rect">
+            <a:avLst/>
+          </a:prstGeom>
+          <a:solidFill xmlns:a="http://schemas.openxmlformats.org/drawingml/2006/main">
+            <a:srgbClr val="00A2EB"/>
+          </a:solidFill>
+          <a:ln xmlns:a="http://schemas.openxmlformats.org/drawingml/2006/main" w="0">
+            <a:solidFill>
+              <a:srgbClr val="00A2EB"/>
+            </a:solidFill>
+            <a:prstDash val="solid"/>
+          </a:ln>
+        </p:spPr>
+      </p:sp>
+      <p:sp>
+        <p:nvSpPr>
+          <p:cNvPr id="32" name="">
+            <a:extLst xmlns:a="http://schemas.openxmlformats.org/drawingml/2006/main">
+              <a:ext uri="{FF2B5EF4-FFF2-40B4-BE49-F238E27FC236}">
+                <a16:creationId xmlns:a16="http://schemas.microsoft.com/office/drawing/2014/main" id="{49281B64-2F0F-4357-A085-C65451F28236}"/>
+              </a:ext>
+            </a:extLst>
+          </p:cNvPr>
+          <p:cNvSpPr>
+            <a:spLocks xmlns:a="http://schemas.openxmlformats.org/drawingml/2006/main" noGrp="1"/>
+          </p:cNvSpPr>
+          <p:nvPr/>
+        </p:nvSpPr>
+        <p:spPr>
+          <a:xfrm xmlns:a="http://schemas.openxmlformats.org/drawingml/2006/main">
+            <a:off x="971550" y="8058150"/>
+            <a:ext cx="3714750" cy="323850"/>
           </a:xfrm>
           <a:prstGeom xmlns:a="http://schemas.openxmlformats.org/drawingml/2006/main" prst="rect">
             <a:avLst/>
@@ -8572,1308 +8665,6 @@
               <a:buNone/>
               <a:defRPr sz="1200" b="0">
                 <a:solidFill>
-                  <a:srgbClr val="1F40CB"/>
-                </a:solidFill>
-                <a:latin typeface="Calibri"/>
-                <a:ea typeface="Calibri"/>
-                <a:cs typeface="Calibri"/>
-              </a:defRPr>
-            </a:pPr>
-            <a:r>
-              <a:rPr sz="1200" b="0">
-                <a:solidFill>
-                  <a:srgbClr val="1F40CB"/>
-                </a:solidFill>
-                <a:latin typeface="Calibri"/>
-                <a:ea typeface="Calibri"/>
-                <a:cs typeface="Calibri"/>
-              </a:rPr>
-              <a:t>mission + typed steps</a:t>
-            </a:r>
-          </a:p>
-        </p:txBody>
-      </p:sp>
-      <p:sp>
-        <p:nvSpPr>
-          <p:cNvPr id="7" name="ingestion-2">
-            <a:extLst xmlns:a="http://schemas.openxmlformats.org/drawingml/2006/main">
-              <a:ext uri="{FF2B5EF4-FFF2-40B4-BE49-F238E27FC236}">
-                <a16:creationId xmlns:a16="http://schemas.microsoft.com/office/drawing/2014/main" id="{B39DEECB-E0D1-415A-8F2A-C8075A6D97BA}"/>
-              </a:ext>
-            </a:extLst>
-          </p:cNvPr>
-          <p:cNvSpPr>
-            <a:spLocks xmlns:a="http://schemas.openxmlformats.org/drawingml/2006/main" noGrp="1"/>
-          </p:cNvSpPr>
-          <p:nvPr/>
-        </p:nvSpPr>
-        <p:spPr>
-          <a:xfrm xmlns:a="http://schemas.openxmlformats.org/drawingml/2006/main">
-            <a:off x="3810000" y="3086100"/>
-            <a:ext cx="2247900" cy="2266950"/>
-          </a:xfrm>
-          <a:prstGeom xmlns:a="http://schemas.openxmlformats.org/drawingml/2006/main" prst="roundRect">
-            <a:avLst>
-              <a:gd name="adj" fmla="val 5085"/>
-            </a:avLst>
-          </a:prstGeom>
-          <a:solidFill xmlns:a="http://schemas.openxmlformats.org/drawingml/2006/main">
-            <a:srgbClr val="FFFFFF"/>
-          </a:solidFill>
-          <a:ln xmlns:a="http://schemas.openxmlformats.org/drawingml/2006/main" w="9525">
-            <a:solidFill>
-              <a:srgbClr val="E4E7E9"/>
-            </a:solidFill>
-            <a:prstDash val="solid"/>
-          </a:ln>
-        </p:spPr>
-      </p:sp>
-      <p:sp>
-        <p:nvSpPr>
-          <p:cNvPr id="8" name="">
-            <a:extLst xmlns:a="http://schemas.openxmlformats.org/drawingml/2006/main">
-              <a:ext uri="{FF2B5EF4-FFF2-40B4-BE49-F238E27FC236}">
-                <a16:creationId xmlns:a16="http://schemas.microsoft.com/office/drawing/2014/main" id="{18679081-8A68-4B7E-9199-340CF95714DE}"/>
-              </a:ext>
-            </a:extLst>
-          </p:cNvPr>
-          <p:cNvSpPr>
-            <a:spLocks xmlns:a="http://schemas.openxmlformats.org/drawingml/2006/main" noGrp="1"/>
-          </p:cNvSpPr>
-          <p:nvPr/>
-        </p:nvSpPr>
-        <p:spPr>
-          <a:xfrm xmlns:a="http://schemas.openxmlformats.org/drawingml/2006/main">
-            <a:off x="4000500" y="3295650"/>
-            <a:ext cx="514350" cy="285750"/>
-          </a:xfrm>
-          <a:prstGeom xmlns:a="http://schemas.openxmlformats.org/drawingml/2006/main" prst="rect">
-            <a:avLst/>
-          </a:prstGeom>
-          <a:noFill xmlns:a="http://schemas.openxmlformats.org/drawingml/2006/main"/>
-          <a:ln xmlns:a="http://schemas.openxmlformats.org/drawingml/2006/main" w="0">
-            <a:noFill/>
-            <a:prstDash val="solid"/>
-          </a:ln>
-        </p:spPr>
-        <p:txBody>
-          <a:bodyPr xmlns:a="http://schemas.openxmlformats.org/drawingml/2006/main" wrap="square" lIns="0" tIns="0" rIns="0" bIns="0" anchor="ctr">
-            <a:noAutofit/>
-          </a:bodyPr>
-          <a:lstStyle xmlns:a="http://schemas.openxmlformats.org/drawingml/2006/main"/>
-          <a:p xmlns:a="http://schemas.openxmlformats.org/drawingml/2006/main">
-            <a:pPr algn="l">
-              <a:lnSpc>
-                <a:spcPct val="100000"/>
-              </a:lnSpc>
-              <a:buNone/>
-              <a:defRPr sz="1350" b="1">
-                <a:solidFill>
-                  <a:srgbClr val="00A2EB"/>
-                </a:solidFill>
-                <a:latin typeface="Calibri"/>
-                <a:ea typeface="Calibri"/>
-                <a:cs typeface="Calibri"/>
-              </a:defRPr>
-            </a:pPr>
-            <a:r>
-              <a:rPr sz="1800" b="1">
-                <a:solidFill>
-                  <a:srgbClr val="00A2EB"/>
-                </a:solidFill>
-                <a:latin typeface="Calibri"/>
-                <a:ea typeface="Calibri"/>
-                <a:cs typeface="Calibri"/>
-              </a:rPr>
-              <a:t>02</a:t>
-            </a:r>
-          </a:p>
-        </p:txBody>
-      </p:sp>
-      <p:sp>
-        <p:nvSpPr>
-          <p:cNvPr id="9" name="">
-            <a:extLst xmlns:a="http://schemas.openxmlformats.org/drawingml/2006/main">
-              <a:ext uri="{FF2B5EF4-FFF2-40B4-BE49-F238E27FC236}">
-                <a16:creationId xmlns:a16="http://schemas.microsoft.com/office/drawing/2014/main" id="{ED095E54-44DC-4092-9EB7-0C81E4B47710}"/>
-              </a:ext>
-            </a:extLst>
-          </p:cNvPr>
-          <p:cNvSpPr>
-            <a:spLocks xmlns:a="http://schemas.openxmlformats.org/drawingml/2006/main" noGrp="1"/>
-          </p:cNvSpPr>
-          <p:nvPr/>
-        </p:nvSpPr>
-        <p:spPr>
-          <a:xfrm xmlns:a="http://schemas.openxmlformats.org/drawingml/2006/main">
-            <a:off x="3924300" y="3752850"/>
-            <a:ext cx="2019300" cy="685800"/>
-          </a:xfrm>
-          <a:prstGeom xmlns:a="http://schemas.openxmlformats.org/drawingml/2006/main" prst="rect">
-            <a:avLst/>
-          </a:prstGeom>
-          <a:noFill xmlns:a="http://schemas.openxmlformats.org/drawingml/2006/main"/>
-          <a:ln xmlns:a="http://schemas.openxmlformats.org/drawingml/2006/main" w="0">
-            <a:noFill/>
-            <a:prstDash val="solid"/>
-          </a:ln>
-        </p:spPr>
-        <p:txBody>
-          <a:bodyPr xmlns:a="http://schemas.openxmlformats.org/drawingml/2006/main" wrap="square" lIns="0" tIns="0" rIns="0" bIns="0" anchor="ctr">
-            <a:normAutofit fontScale="100000"/>
-          </a:bodyPr>
-          <a:lstStyle xmlns:a="http://schemas.openxmlformats.org/drawingml/2006/main"/>
-          <a:p xmlns:a="http://schemas.openxmlformats.org/drawingml/2006/main">
-            <a:pPr algn="l">
-              <a:lnSpc>
-                <a:spcPct val="100000"/>
-              </a:lnSpc>
-              <a:buNone/>
-              <a:defRPr sz="1950" b="1">
-                <a:solidFill>
-                  <a:srgbClr val="051C2A"/>
-                </a:solidFill>
-                <a:latin typeface="Calibri"/>
-                <a:ea typeface="Calibri"/>
-                <a:cs typeface="Calibri"/>
-              </a:defRPr>
-            </a:pPr>
-            <a:r>
-              <a:rPr sz="1950" b="1">
-                <a:solidFill>
-                  <a:srgbClr val="051C2A"/>
-                </a:solidFill>
-                <a:latin typeface="Calibri"/>
-                <a:ea typeface="Calibri"/>
-                <a:cs typeface="Calibri"/>
-              </a:rPr>
-              <a:t>PLAN GATE</a:t>
-            </a:r>
-          </a:p>
-        </p:txBody>
-      </p:sp>
-      <p:sp>
-        <p:nvSpPr>
-          <p:cNvPr id="10" name="">
-            <a:extLst xmlns:a="http://schemas.openxmlformats.org/drawingml/2006/main">
-              <a:ext uri="{FF2B5EF4-FFF2-40B4-BE49-F238E27FC236}">
-                <a16:creationId xmlns:a16="http://schemas.microsoft.com/office/drawing/2014/main" id="{4DB65E8E-6BA9-40DB-99F9-46D3397B13A3}"/>
-              </a:ext>
-            </a:extLst>
-          </p:cNvPr>
-          <p:cNvSpPr>
-            <a:spLocks xmlns:a="http://schemas.openxmlformats.org/drawingml/2006/main" noGrp="1"/>
-          </p:cNvSpPr>
-          <p:nvPr/>
-        </p:nvSpPr>
-        <p:spPr>
-          <a:xfrm xmlns:a="http://schemas.openxmlformats.org/drawingml/2006/main">
-            <a:off x="4000500" y="4610100"/>
-            <a:ext cx="1866900" cy="514350"/>
-          </a:xfrm>
-          <a:prstGeom xmlns:a="http://schemas.openxmlformats.org/drawingml/2006/main" prst="rect">
-            <a:avLst/>
-          </a:prstGeom>
-          <a:noFill xmlns:a="http://schemas.openxmlformats.org/drawingml/2006/main"/>
-          <a:ln xmlns:a="http://schemas.openxmlformats.org/drawingml/2006/main" w="0">
-            <a:noFill/>
-            <a:prstDash val="solid"/>
-          </a:ln>
-        </p:spPr>
-        <p:txBody>
-          <a:bodyPr xmlns:a="http://schemas.openxmlformats.org/drawingml/2006/main" wrap="square" lIns="0" tIns="0" rIns="0" bIns="0" anchor="ctr">
-            <a:normAutofit fontScale="100000"/>
-          </a:bodyPr>
-          <a:lstStyle xmlns:a="http://schemas.openxmlformats.org/drawingml/2006/main"/>
-          <a:p xmlns:a="http://schemas.openxmlformats.org/drawingml/2006/main">
-            <a:pPr algn="l">
-              <a:lnSpc>
-                <a:spcPct val="100000"/>
-              </a:lnSpc>
-              <a:buNone/>
-              <a:defRPr sz="1200" b="0">
-                <a:solidFill>
-                  <a:srgbClr val="1F40CB"/>
-                </a:solidFill>
-                <a:latin typeface="Calibri"/>
-                <a:ea typeface="Calibri"/>
-                <a:cs typeface="Calibri"/>
-              </a:defRPr>
-            </a:pPr>
-            <a:r>
-              <a:rPr sz="1200" b="0">
-                <a:solidFill>
-                  <a:srgbClr val="1F40CB"/>
-                </a:solidFill>
-                <a:latin typeface="Calibri"/>
-                <a:ea typeface="Calibri"/>
-                <a:cs typeface="Calibri"/>
-              </a:rPr>
-              <a:t>schema + budget</a:t>
-            </a:r>
-          </a:p>
-        </p:txBody>
-      </p:sp>
-      <p:sp>
-        <p:nvSpPr>
-          <p:cNvPr id="11" name="ingestion-3">
-            <a:extLst xmlns:a="http://schemas.openxmlformats.org/drawingml/2006/main">
-              <a:ext uri="{FF2B5EF4-FFF2-40B4-BE49-F238E27FC236}">
-                <a16:creationId xmlns:a16="http://schemas.microsoft.com/office/drawing/2014/main" id="{D4342A97-3791-461F-A305-9671DA4948CE}"/>
-              </a:ext>
-            </a:extLst>
-          </p:cNvPr>
-          <p:cNvSpPr>
-            <a:spLocks xmlns:a="http://schemas.openxmlformats.org/drawingml/2006/main" noGrp="1"/>
-          </p:cNvSpPr>
-          <p:nvPr/>
-        </p:nvSpPr>
-        <p:spPr>
-          <a:xfrm xmlns:a="http://schemas.openxmlformats.org/drawingml/2006/main">
-            <a:off x="6629400" y="3086100"/>
-            <a:ext cx="2247900" cy="2266950"/>
-          </a:xfrm>
-          <a:prstGeom xmlns:a="http://schemas.openxmlformats.org/drawingml/2006/main" prst="roundRect">
-            <a:avLst>
-              <a:gd name="adj" fmla="val 5085"/>
-            </a:avLst>
-          </a:prstGeom>
-          <a:solidFill xmlns:a="http://schemas.openxmlformats.org/drawingml/2006/main">
-            <a:srgbClr val="062433"/>
-          </a:solidFill>
-          <a:ln xmlns:a="http://schemas.openxmlformats.org/drawingml/2006/main" w="9525">
-            <a:solidFill>
-              <a:srgbClr val="062433"/>
-            </a:solidFill>
-            <a:prstDash val="solid"/>
-          </a:ln>
-        </p:spPr>
-      </p:sp>
-      <p:sp>
-        <p:nvSpPr>
-          <p:cNvPr id="12" name="">
-            <a:extLst xmlns:a="http://schemas.openxmlformats.org/drawingml/2006/main">
-              <a:ext uri="{FF2B5EF4-FFF2-40B4-BE49-F238E27FC236}">
-                <a16:creationId xmlns:a16="http://schemas.microsoft.com/office/drawing/2014/main" id="{64E49A95-2D88-4387-8BD5-FA749ABD0960}"/>
-              </a:ext>
-            </a:extLst>
-          </p:cNvPr>
-          <p:cNvSpPr>
-            <a:spLocks xmlns:a="http://schemas.openxmlformats.org/drawingml/2006/main" noGrp="1"/>
-          </p:cNvSpPr>
-          <p:nvPr/>
-        </p:nvSpPr>
-        <p:spPr>
-          <a:xfrm xmlns:a="http://schemas.openxmlformats.org/drawingml/2006/main">
-            <a:off x="6819900" y="3295650"/>
-            <a:ext cx="514350" cy="285750"/>
-          </a:xfrm>
-          <a:prstGeom xmlns:a="http://schemas.openxmlformats.org/drawingml/2006/main" prst="rect">
-            <a:avLst/>
-          </a:prstGeom>
-          <a:noFill xmlns:a="http://schemas.openxmlformats.org/drawingml/2006/main"/>
-          <a:ln xmlns:a="http://schemas.openxmlformats.org/drawingml/2006/main" w="0">
-            <a:noFill/>
-            <a:prstDash val="solid"/>
-          </a:ln>
-        </p:spPr>
-        <p:txBody>
-          <a:bodyPr xmlns:a="http://schemas.openxmlformats.org/drawingml/2006/main" wrap="square" lIns="0" tIns="0" rIns="0" bIns="0" anchor="ctr">
-            <a:noAutofit/>
-          </a:bodyPr>
-          <a:lstStyle xmlns:a="http://schemas.openxmlformats.org/drawingml/2006/main"/>
-          <a:p xmlns:a="http://schemas.openxmlformats.org/drawingml/2006/main">
-            <a:pPr algn="l">
-              <a:lnSpc>
-                <a:spcPct val="100000"/>
-              </a:lnSpc>
-              <a:buNone/>
-              <a:defRPr sz="1350" b="1">
-                <a:solidFill>
-                  <a:srgbClr val="00A2EB"/>
-                </a:solidFill>
-                <a:latin typeface="Calibri"/>
-                <a:ea typeface="Calibri"/>
-                <a:cs typeface="Calibri"/>
-              </a:defRPr>
-            </a:pPr>
-            <a:r>
-              <a:rPr sz="1800" b="1">
-                <a:solidFill>
-                  <a:srgbClr val="00A2EB"/>
-                </a:solidFill>
-                <a:latin typeface="Calibri"/>
-                <a:ea typeface="Calibri"/>
-                <a:cs typeface="Calibri"/>
-              </a:rPr>
-              <a:t>03</a:t>
-            </a:r>
-          </a:p>
-        </p:txBody>
-      </p:sp>
-      <p:sp>
-        <p:nvSpPr>
-          <p:cNvPr id="13" name="">
-            <a:extLst xmlns:a="http://schemas.openxmlformats.org/drawingml/2006/main">
-              <a:ext uri="{FF2B5EF4-FFF2-40B4-BE49-F238E27FC236}">
-                <a16:creationId xmlns:a16="http://schemas.microsoft.com/office/drawing/2014/main" id="{572D3874-F985-4CD0-BBFF-D59F5B7B32BE}"/>
-              </a:ext>
-            </a:extLst>
-          </p:cNvPr>
-          <p:cNvSpPr>
-            <a:spLocks xmlns:a="http://schemas.openxmlformats.org/drawingml/2006/main" noGrp="1"/>
-          </p:cNvSpPr>
-          <p:nvPr/>
-        </p:nvSpPr>
-        <p:spPr>
-          <a:xfrm xmlns:a="http://schemas.openxmlformats.org/drawingml/2006/main">
-            <a:off x="6743700" y="3752850"/>
-            <a:ext cx="2019300" cy="685800"/>
-          </a:xfrm>
-          <a:prstGeom xmlns:a="http://schemas.openxmlformats.org/drawingml/2006/main" prst="rect">
-            <a:avLst/>
-          </a:prstGeom>
-          <a:noFill xmlns:a="http://schemas.openxmlformats.org/drawingml/2006/main"/>
-          <a:ln xmlns:a="http://schemas.openxmlformats.org/drawingml/2006/main" w="0">
-            <a:noFill/>
-            <a:prstDash val="solid"/>
-          </a:ln>
-        </p:spPr>
-        <p:txBody>
-          <a:bodyPr xmlns:a="http://schemas.openxmlformats.org/drawingml/2006/main" wrap="square" lIns="0" tIns="0" rIns="0" bIns="0" anchor="ctr">
-            <a:noAutofit/>
-          </a:bodyPr>
-          <a:lstStyle xmlns:a="http://schemas.openxmlformats.org/drawingml/2006/main"/>
-          <a:p xmlns:a="http://schemas.openxmlformats.org/drawingml/2006/main">
-            <a:pPr algn="l">
-              <a:lnSpc>
-                <a:spcPct val="100000"/>
-              </a:lnSpc>
-              <a:buNone/>
-              <a:defRPr sz="1650" b="1">
-                <a:solidFill>
-                  <a:srgbClr val="FFFFFF"/>
-                </a:solidFill>
-                <a:latin typeface="Calibri"/>
-                <a:ea typeface="Calibri"/>
-                <a:cs typeface="Calibri"/>
-              </a:defRPr>
-            </a:pPr>
-            <a:r>
-              <a:rPr sz="1800" b="1">
-                <a:solidFill>
-                  <a:srgbClr val="FFFFFF"/>
-                </a:solidFill>
-                <a:latin typeface="Calibri"/>
-                <a:ea typeface="Calibri"/>
-                <a:cs typeface="Calibri"/>
-              </a:rPr>
-              <a:t>TOOL</a:t>
-            </a:r>
-          </a:p>
-        </p:txBody>
-      </p:sp>
-      <p:sp>
-        <p:nvSpPr>
-          <p:cNvPr id="14" name="">
-            <a:extLst xmlns:a="http://schemas.openxmlformats.org/drawingml/2006/main">
-              <a:ext uri="{FF2B5EF4-FFF2-40B4-BE49-F238E27FC236}">
-                <a16:creationId xmlns:a16="http://schemas.microsoft.com/office/drawing/2014/main" id="{9599AF29-91DE-47C0-8189-B0778BB52724}"/>
-              </a:ext>
-            </a:extLst>
-          </p:cNvPr>
-          <p:cNvSpPr>
-            <a:spLocks xmlns:a="http://schemas.openxmlformats.org/drawingml/2006/main" noGrp="1"/>
-          </p:cNvSpPr>
-          <p:nvPr/>
-        </p:nvSpPr>
-        <p:spPr>
-          <a:xfrm xmlns:a="http://schemas.openxmlformats.org/drawingml/2006/main">
-            <a:off x="6819900" y="4610100"/>
-            <a:ext cx="1866900" cy="514350"/>
-          </a:xfrm>
-          <a:prstGeom xmlns:a="http://schemas.openxmlformats.org/drawingml/2006/main" prst="rect">
-            <a:avLst/>
-          </a:prstGeom>
-          <a:noFill xmlns:a="http://schemas.openxmlformats.org/drawingml/2006/main"/>
-          <a:ln xmlns:a="http://schemas.openxmlformats.org/drawingml/2006/main" w="0">
-            <a:noFill/>
-            <a:prstDash val="solid"/>
-          </a:ln>
-        </p:spPr>
-        <p:txBody>
-          <a:bodyPr xmlns:a="http://schemas.openxmlformats.org/drawingml/2006/main" wrap="square" lIns="0" tIns="0" rIns="0" bIns="0" anchor="ctr">
-            <a:normAutofit fontScale="100000"/>
-          </a:bodyPr>
-          <a:lstStyle xmlns:a="http://schemas.openxmlformats.org/drawingml/2006/main"/>
-          <a:p xmlns:a="http://schemas.openxmlformats.org/drawingml/2006/main">
-            <a:pPr algn="l">
-              <a:lnSpc>
-                <a:spcPct val="100000"/>
-              </a:lnSpc>
-              <a:buNone/>
-              <a:defRPr sz="1200" b="0">
-                <a:solidFill>
-                  <a:srgbClr val="00A2EB"/>
-                </a:solidFill>
-                <a:latin typeface="Calibri"/>
-                <a:ea typeface="Calibri"/>
-                <a:cs typeface="Calibri"/>
-              </a:defRPr>
-            </a:pPr>
-            <a:r>
-              <a:rPr sz="1200" b="0">
-                <a:solidFill>
-                  <a:srgbClr val="00A2EB"/>
-                </a:solidFill>
-                <a:latin typeface="Calibri"/>
-                <a:ea typeface="Calibri"/>
-                <a:cs typeface="Calibri"/>
-              </a:rPr>
-              <a:t>unsupported_metric</a:t>
-            </a:r>
-          </a:p>
-        </p:txBody>
-      </p:sp>
-      <p:sp>
-        <p:nvSpPr>
-          <p:cNvPr id="15" name="ingestion-4">
-            <a:extLst xmlns:a="http://schemas.openxmlformats.org/drawingml/2006/main">
-              <a:ext uri="{FF2B5EF4-FFF2-40B4-BE49-F238E27FC236}">
-                <a16:creationId xmlns:a16="http://schemas.microsoft.com/office/drawing/2014/main" id="{7952DE37-BD86-481C-A575-8709971DD74E}"/>
-              </a:ext>
-            </a:extLst>
-          </p:cNvPr>
-          <p:cNvSpPr>
-            <a:spLocks xmlns:a="http://schemas.openxmlformats.org/drawingml/2006/main" noGrp="1"/>
-          </p:cNvSpPr>
-          <p:nvPr/>
-        </p:nvSpPr>
-        <p:spPr>
-          <a:xfrm xmlns:a="http://schemas.openxmlformats.org/drawingml/2006/main">
-            <a:off x="9448800" y="3086100"/>
-            <a:ext cx="2247900" cy="2266950"/>
-          </a:xfrm>
-          <a:prstGeom xmlns:a="http://schemas.openxmlformats.org/drawingml/2006/main" prst="roundRect">
-            <a:avLst>
-              <a:gd name="adj" fmla="val 5085"/>
-            </a:avLst>
-          </a:prstGeom>
-          <a:solidFill xmlns:a="http://schemas.openxmlformats.org/drawingml/2006/main">
-            <a:srgbClr val="FFFFFF"/>
-          </a:solidFill>
-          <a:ln xmlns:a="http://schemas.openxmlformats.org/drawingml/2006/main" w="9525">
-            <a:solidFill>
-              <a:srgbClr val="E4E7E9"/>
-            </a:solidFill>
-            <a:prstDash val="solid"/>
-          </a:ln>
-        </p:spPr>
-      </p:sp>
-      <p:sp>
-        <p:nvSpPr>
-          <p:cNvPr id="16" name="">
-            <a:extLst xmlns:a="http://schemas.openxmlformats.org/drawingml/2006/main">
-              <a:ext uri="{FF2B5EF4-FFF2-40B4-BE49-F238E27FC236}">
-                <a16:creationId xmlns:a16="http://schemas.microsoft.com/office/drawing/2014/main" id="{62EC2EC9-18A1-4F72-A64D-AF536DDC8F61}"/>
-              </a:ext>
-            </a:extLst>
-          </p:cNvPr>
-          <p:cNvSpPr>
-            <a:spLocks xmlns:a="http://schemas.openxmlformats.org/drawingml/2006/main" noGrp="1"/>
-          </p:cNvSpPr>
-          <p:nvPr/>
-        </p:nvSpPr>
-        <p:spPr>
-          <a:xfrm xmlns:a="http://schemas.openxmlformats.org/drawingml/2006/main">
-            <a:off x="9639300" y="3295650"/>
-            <a:ext cx="514350" cy="285750"/>
-          </a:xfrm>
-          <a:prstGeom xmlns:a="http://schemas.openxmlformats.org/drawingml/2006/main" prst="rect">
-            <a:avLst/>
-          </a:prstGeom>
-          <a:noFill xmlns:a="http://schemas.openxmlformats.org/drawingml/2006/main"/>
-          <a:ln xmlns:a="http://schemas.openxmlformats.org/drawingml/2006/main" w="0">
-            <a:noFill/>
-            <a:prstDash val="solid"/>
-          </a:ln>
-        </p:spPr>
-        <p:txBody>
-          <a:bodyPr xmlns:a="http://schemas.openxmlformats.org/drawingml/2006/main" wrap="square" lIns="0" tIns="0" rIns="0" bIns="0" anchor="ctr">
-            <a:noAutofit/>
-          </a:bodyPr>
-          <a:lstStyle xmlns:a="http://schemas.openxmlformats.org/drawingml/2006/main"/>
-          <a:p xmlns:a="http://schemas.openxmlformats.org/drawingml/2006/main">
-            <a:pPr algn="l">
-              <a:lnSpc>
-                <a:spcPct val="100000"/>
-              </a:lnSpc>
-              <a:buNone/>
-              <a:defRPr sz="1350" b="1">
-                <a:solidFill>
-                  <a:srgbClr val="00A2EB"/>
-                </a:solidFill>
-                <a:latin typeface="Calibri"/>
-                <a:ea typeface="Calibri"/>
-                <a:cs typeface="Calibri"/>
-              </a:defRPr>
-            </a:pPr>
-            <a:r>
-              <a:rPr sz="1800" b="1">
-                <a:solidFill>
-                  <a:srgbClr val="00A2EB"/>
-                </a:solidFill>
-                <a:latin typeface="Calibri"/>
-                <a:ea typeface="Calibri"/>
-                <a:cs typeface="Calibri"/>
-              </a:rPr>
-              <a:t>04</a:t>
-            </a:r>
-          </a:p>
-        </p:txBody>
-      </p:sp>
-      <p:sp>
-        <p:nvSpPr>
-          <p:cNvPr id="17" name="">
-            <a:extLst xmlns:a="http://schemas.openxmlformats.org/drawingml/2006/main">
-              <a:ext uri="{FF2B5EF4-FFF2-40B4-BE49-F238E27FC236}">
-                <a16:creationId xmlns:a16="http://schemas.microsoft.com/office/drawing/2014/main" id="{8540FD5A-1C0F-4BE1-B862-685F20D0F43C}"/>
-              </a:ext>
-            </a:extLst>
-          </p:cNvPr>
-          <p:cNvSpPr>
-            <a:spLocks xmlns:a="http://schemas.openxmlformats.org/drawingml/2006/main" noGrp="1"/>
-          </p:cNvSpPr>
-          <p:nvPr/>
-        </p:nvSpPr>
-        <p:spPr>
-          <a:xfrm xmlns:a="http://schemas.openxmlformats.org/drawingml/2006/main">
-            <a:off x="9563100" y="3752850"/>
-            <a:ext cx="2019300" cy="685800"/>
-          </a:xfrm>
-          <a:prstGeom xmlns:a="http://schemas.openxmlformats.org/drawingml/2006/main" prst="rect">
-            <a:avLst/>
-          </a:prstGeom>
-          <a:noFill xmlns:a="http://schemas.openxmlformats.org/drawingml/2006/main"/>
-          <a:ln xmlns:a="http://schemas.openxmlformats.org/drawingml/2006/main" w="0">
-            <a:noFill/>
-            <a:prstDash val="solid"/>
-          </a:ln>
-        </p:spPr>
-        <p:txBody>
-          <a:bodyPr xmlns:a="http://schemas.openxmlformats.org/drawingml/2006/main" wrap="square" lIns="0" tIns="0" rIns="0" bIns="0" anchor="ctr">
-            <a:normAutofit fontScale="100000"/>
-          </a:bodyPr>
-          <a:lstStyle xmlns:a="http://schemas.openxmlformats.org/drawingml/2006/main"/>
-          <a:p xmlns:a="http://schemas.openxmlformats.org/drawingml/2006/main">
-            <a:pPr algn="l">
-              <a:lnSpc>
-                <a:spcPct val="100000"/>
-              </a:lnSpc>
-              <a:buNone/>
-              <a:defRPr sz="1950" b="1">
-                <a:solidFill>
-                  <a:srgbClr val="051C2A"/>
-                </a:solidFill>
-                <a:latin typeface="Calibri"/>
-                <a:ea typeface="Calibri"/>
-                <a:cs typeface="Calibri"/>
-              </a:defRPr>
-            </a:pPr>
-            <a:r>
-              <a:rPr sz="1950" b="1">
-                <a:solidFill>
-                  <a:srgbClr val="051C2A"/>
-                </a:solidFill>
-                <a:latin typeface="Calibri"/>
-                <a:ea typeface="Calibri"/>
-                <a:cs typeface="Calibri"/>
-              </a:rPr>
-              <a:t>REPLAN + GATE</a:t>
-            </a:r>
-          </a:p>
-        </p:txBody>
-      </p:sp>
-      <p:sp>
-        <p:nvSpPr>
-          <p:cNvPr id="18" name="">
-            <a:extLst xmlns:a="http://schemas.openxmlformats.org/drawingml/2006/main">
-              <a:ext uri="{FF2B5EF4-FFF2-40B4-BE49-F238E27FC236}">
-                <a16:creationId xmlns:a16="http://schemas.microsoft.com/office/drawing/2014/main" id="{67E52B70-645C-40F7-B0DE-1D1D177875CC}"/>
-              </a:ext>
-            </a:extLst>
-          </p:cNvPr>
-          <p:cNvSpPr>
-            <a:spLocks xmlns:a="http://schemas.openxmlformats.org/drawingml/2006/main" noGrp="1"/>
-          </p:cNvSpPr>
-          <p:nvPr/>
-        </p:nvSpPr>
-        <p:spPr>
-          <a:xfrm xmlns:a="http://schemas.openxmlformats.org/drawingml/2006/main">
-            <a:off x="9639300" y="4610100"/>
-            <a:ext cx="1866900" cy="514350"/>
-          </a:xfrm>
-          <a:prstGeom xmlns:a="http://schemas.openxmlformats.org/drawingml/2006/main" prst="rect">
-            <a:avLst/>
-          </a:prstGeom>
-          <a:noFill xmlns:a="http://schemas.openxmlformats.org/drawingml/2006/main"/>
-          <a:ln xmlns:a="http://schemas.openxmlformats.org/drawingml/2006/main" w="0">
-            <a:noFill/>
-            <a:prstDash val="solid"/>
-          </a:ln>
-        </p:spPr>
-        <p:txBody>
-          <a:bodyPr xmlns:a="http://schemas.openxmlformats.org/drawingml/2006/main" wrap="square" lIns="0" tIns="0" rIns="0" bIns="0" anchor="ctr">
-            <a:normAutofit fontScale="100000"/>
-          </a:bodyPr>
-          <a:lstStyle xmlns:a="http://schemas.openxmlformats.org/drawingml/2006/main"/>
-          <a:p xmlns:a="http://schemas.openxmlformats.org/drawingml/2006/main">
-            <a:pPr algn="l">
-              <a:lnSpc>
-                <a:spcPct val="100000"/>
-              </a:lnSpc>
-              <a:buNone/>
-              <a:defRPr sz="1200" b="0">
-                <a:solidFill>
-                  <a:srgbClr val="1F40CB"/>
-                </a:solidFill>
-                <a:latin typeface="Calibri"/>
-                <a:ea typeface="Calibri"/>
-                <a:cs typeface="Calibri"/>
-              </a:defRPr>
-            </a:pPr>
-            <a:r>
-              <a:rPr sz="1200" b="0">
-                <a:solidFill>
-                  <a:srgbClr val="1F40CB"/>
-                </a:solidFill>
-                <a:latin typeface="Calibri"/>
-                <a:ea typeface="Calibri"/>
-                <a:cs typeface="Calibri"/>
-              </a:rPr>
-              <a:t>tail + evidence</a:t>
-            </a:r>
-          </a:p>
-        </p:txBody>
-      </p:sp>
-      <p:sp>
-        <p:nvSpPr>
-          <p:cNvPr id="19" name="ingestion-5">
-            <a:extLst xmlns:a="http://schemas.openxmlformats.org/drawingml/2006/main">
-              <a:ext uri="{FF2B5EF4-FFF2-40B4-BE49-F238E27FC236}">
-                <a16:creationId xmlns:a16="http://schemas.microsoft.com/office/drawing/2014/main" id="{43F7E1B1-E237-4A79-B0C4-38965CF32D74}"/>
-              </a:ext>
-            </a:extLst>
-          </p:cNvPr>
-          <p:cNvSpPr>
-            <a:spLocks xmlns:a="http://schemas.openxmlformats.org/drawingml/2006/main" noGrp="1"/>
-          </p:cNvSpPr>
-          <p:nvPr/>
-        </p:nvSpPr>
-        <p:spPr>
-          <a:xfrm xmlns:a="http://schemas.openxmlformats.org/drawingml/2006/main">
-            <a:off x="12268200" y="3086100"/>
-            <a:ext cx="2247900" cy="2266950"/>
-          </a:xfrm>
-          <a:prstGeom xmlns:a="http://schemas.openxmlformats.org/drawingml/2006/main" prst="roundRect">
-            <a:avLst>
-              <a:gd name="adj" fmla="val 5085"/>
-            </a:avLst>
-          </a:prstGeom>
-          <a:solidFill xmlns:a="http://schemas.openxmlformats.org/drawingml/2006/main">
-            <a:srgbClr val="FFFFFF"/>
-          </a:solidFill>
-          <a:ln xmlns:a="http://schemas.openxmlformats.org/drawingml/2006/main" w="19050">
-            <a:solidFill>
-              <a:srgbClr val="F07D00"/>
-            </a:solidFill>
-            <a:prstDash val="solid"/>
-          </a:ln>
-        </p:spPr>
-      </p:sp>
-      <p:sp>
-        <p:nvSpPr>
-          <p:cNvPr id="20" name="">
-            <a:extLst xmlns:a="http://schemas.openxmlformats.org/drawingml/2006/main">
-              <a:ext uri="{FF2B5EF4-FFF2-40B4-BE49-F238E27FC236}">
-                <a16:creationId xmlns:a16="http://schemas.microsoft.com/office/drawing/2014/main" id="{51764D39-05B0-4F08-BC2B-2221BE2F38D6}"/>
-              </a:ext>
-            </a:extLst>
-          </p:cNvPr>
-          <p:cNvSpPr>
-            <a:spLocks xmlns:a="http://schemas.openxmlformats.org/drawingml/2006/main" noGrp="1"/>
-          </p:cNvSpPr>
-          <p:nvPr/>
-        </p:nvSpPr>
-        <p:spPr>
-          <a:xfrm xmlns:a="http://schemas.openxmlformats.org/drawingml/2006/main">
-            <a:off x="12458700" y="3295650"/>
-            <a:ext cx="514350" cy="285750"/>
-          </a:xfrm>
-          <a:prstGeom xmlns:a="http://schemas.openxmlformats.org/drawingml/2006/main" prst="rect">
-            <a:avLst/>
-          </a:prstGeom>
-          <a:noFill xmlns:a="http://schemas.openxmlformats.org/drawingml/2006/main"/>
-          <a:ln xmlns:a="http://schemas.openxmlformats.org/drawingml/2006/main" w="0">
-            <a:noFill/>
-            <a:prstDash val="solid"/>
-          </a:ln>
-        </p:spPr>
-        <p:txBody>
-          <a:bodyPr xmlns:a="http://schemas.openxmlformats.org/drawingml/2006/main" wrap="square" lIns="0" tIns="0" rIns="0" bIns="0" anchor="ctr">
-            <a:noAutofit/>
-          </a:bodyPr>
-          <a:lstStyle xmlns:a="http://schemas.openxmlformats.org/drawingml/2006/main"/>
-          <a:p xmlns:a="http://schemas.openxmlformats.org/drawingml/2006/main">
-            <a:pPr algn="l">
-              <a:lnSpc>
-                <a:spcPct val="100000"/>
-              </a:lnSpc>
-              <a:buNone/>
-              <a:defRPr sz="1350" b="1">
-                <a:solidFill>
-                  <a:srgbClr val="00A2EB"/>
-                </a:solidFill>
-                <a:latin typeface="Calibri"/>
-                <a:ea typeface="Calibri"/>
-                <a:cs typeface="Calibri"/>
-              </a:defRPr>
-            </a:pPr>
-            <a:r>
-              <a:rPr sz="1800" b="1">
-                <a:solidFill>
-                  <a:srgbClr val="00A2EB"/>
-                </a:solidFill>
-                <a:latin typeface="Calibri"/>
-                <a:ea typeface="Calibri"/>
-                <a:cs typeface="Calibri"/>
-              </a:rPr>
-              <a:t>05</a:t>
-            </a:r>
-          </a:p>
-        </p:txBody>
-      </p:sp>
-      <p:sp>
-        <p:nvSpPr>
-          <p:cNvPr id="21" name="">
-            <a:extLst xmlns:a="http://schemas.openxmlformats.org/drawingml/2006/main">
-              <a:ext uri="{FF2B5EF4-FFF2-40B4-BE49-F238E27FC236}">
-                <a16:creationId xmlns:a16="http://schemas.microsoft.com/office/drawing/2014/main" id="{C0F4CBB5-9FF7-4C7B-8D8C-5AA3541DD5E4}"/>
-              </a:ext>
-            </a:extLst>
-          </p:cNvPr>
-          <p:cNvSpPr>
-            <a:spLocks xmlns:a="http://schemas.openxmlformats.org/drawingml/2006/main" noGrp="1"/>
-          </p:cNvSpPr>
-          <p:nvPr/>
-        </p:nvSpPr>
-        <p:spPr>
-          <a:xfrm xmlns:a="http://schemas.openxmlformats.org/drawingml/2006/main">
-            <a:off x="12382500" y="3752850"/>
-            <a:ext cx="2019300" cy="685800"/>
-          </a:xfrm>
-          <a:prstGeom xmlns:a="http://schemas.openxmlformats.org/drawingml/2006/main" prst="rect">
-            <a:avLst/>
-          </a:prstGeom>
-          <a:noFill xmlns:a="http://schemas.openxmlformats.org/drawingml/2006/main"/>
-          <a:ln xmlns:a="http://schemas.openxmlformats.org/drawingml/2006/main" w="0">
-            <a:noFill/>
-            <a:prstDash val="solid"/>
-          </a:ln>
-        </p:spPr>
-        <p:txBody>
-          <a:bodyPr xmlns:a="http://schemas.openxmlformats.org/drawingml/2006/main" wrap="square" lIns="0" tIns="0" rIns="0" bIns="0" anchor="ctr">
-            <a:normAutofit fontScale="100000"/>
-          </a:bodyPr>
-          <a:lstStyle xmlns:a="http://schemas.openxmlformats.org/drawingml/2006/main"/>
-          <a:p xmlns:a="http://schemas.openxmlformats.org/drawingml/2006/main">
-            <a:pPr algn="l">
-              <a:lnSpc>
-                <a:spcPct val="100000"/>
-              </a:lnSpc>
-              <a:buNone/>
-              <a:defRPr sz="1950" b="1">
-                <a:solidFill>
-                  <a:srgbClr val="051C2A"/>
-                </a:solidFill>
-                <a:latin typeface="Calibri"/>
-                <a:ea typeface="Calibri"/>
-                <a:cs typeface="Calibri"/>
-              </a:defRPr>
-            </a:pPr>
-            <a:r>
-              <a:rPr sz="1950" b="1">
-                <a:solidFill>
-                  <a:srgbClr val="051C2A"/>
-                </a:solidFill>
-                <a:latin typeface="Calibri"/>
-                <a:ea typeface="Calibri"/>
-                <a:cs typeface="Calibri"/>
-              </a:rPr>
-              <a:t>REPORT</a:t>
-            </a:r>
-          </a:p>
-        </p:txBody>
-      </p:sp>
-      <p:sp>
-        <p:nvSpPr>
-          <p:cNvPr id="22" name="">
-            <a:extLst xmlns:a="http://schemas.openxmlformats.org/drawingml/2006/main">
-              <a:ext uri="{FF2B5EF4-FFF2-40B4-BE49-F238E27FC236}">
-                <a16:creationId xmlns:a16="http://schemas.microsoft.com/office/drawing/2014/main" id="{8856B515-B8BF-4B9C-8D6B-EC909D2B3B4E}"/>
-              </a:ext>
-            </a:extLst>
-          </p:cNvPr>
-          <p:cNvSpPr>
-            <a:spLocks xmlns:a="http://schemas.openxmlformats.org/drawingml/2006/main" noGrp="1"/>
-          </p:cNvSpPr>
-          <p:nvPr/>
-        </p:nvSpPr>
-        <p:spPr>
-          <a:xfrm xmlns:a="http://schemas.openxmlformats.org/drawingml/2006/main">
-            <a:off x="12458700" y="4610100"/>
-            <a:ext cx="1866900" cy="514350"/>
-          </a:xfrm>
-          <a:prstGeom xmlns:a="http://schemas.openxmlformats.org/drawingml/2006/main" prst="rect">
-            <a:avLst/>
-          </a:prstGeom>
-          <a:noFill xmlns:a="http://schemas.openxmlformats.org/drawingml/2006/main"/>
-          <a:ln xmlns:a="http://schemas.openxmlformats.org/drawingml/2006/main" w="0">
-            <a:noFill/>
-            <a:prstDash val="solid"/>
-          </a:ln>
-        </p:spPr>
-        <p:txBody>
-          <a:bodyPr xmlns:a="http://schemas.openxmlformats.org/drawingml/2006/main" wrap="square" lIns="0" tIns="0" rIns="0" bIns="0" anchor="ctr">
-            <a:normAutofit fontScale="100000"/>
-          </a:bodyPr>
-          <a:lstStyle xmlns:a="http://schemas.openxmlformats.org/drawingml/2006/main"/>
-          <a:p xmlns:a="http://schemas.openxmlformats.org/drawingml/2006/main">
-            <a:pPr algn="l">
-              <a:lnSpc>
-                <a:spcPct val="100000"/>
-              </a:lnSpc>
-              <a:buNone/>
-              <a:defRPr sz="1200" b="0">
-                <a:solidFill>
-                  <a:srgbClr val="1F40CB"/>
-                </a:solidFill>
-                <a:latin typeface="Calibri"/>
-                <a:ea typeface="Calibri"/>
-                <a:cs typeface="Calibri"/>
-              </a:defRPr>
-            </a:pPr>
-            <a:r>
-              <a:rPr sz="1200" b="0">
-                <a:solidFill>
-                  <a:srgbClr val="1F40CB"/>
-                </a:solidFill>
-                <a:latin typeface="Calibri"/>
-                <a:ea typeface="Calibri"/>
-                <a:cs typeface="Calibri"/>
-              </a:rPr>
-              <a:t>briefing + citations</a:t>
-            </a:r>
-          </a:p>
-        </p:txBody>
-      </p:sp>
-      <p:cxnSp>
-        <p:nvCxnSpPr>
-          <p:cNvPr id="681" name=""/>
-          <p:cNvCxnSpPr>
-            <a:stCxn xmlns:a="http://schemas.openxmlformats.org/drawingml/2006/main" id="3" idx="3"/>
-            <a:endCxn xmlns:a="http://schemas.openxmlformats.org/drawingml/2006/main" id="7" idx="1"/>
-          </p:cNvCxnSpPr>
-          <p:nvPr/>
-        </p:nvCxnSpPr>
-        <p:spPr>
-          <a:xfrm xmlns:a="http://schemas.openxmlformats.org/drawingml/2006/main">
-            <a:off x="3238500" y="4219575"/>
-            <a:ext cx="571500" cy="0"/>
-          </a:xfrm>
-          <a:prstGeom xmlns:a="http://schemas.openxmlformats.org/drawingml/2006/main" prst="straightConnector1">
-            <a:avLst/>
-          </a:prstGeom>
-          <a:ln xmlns:a="http://schemas.openxmlformats.org/drawingml/2006/main" w="28575">
-            <a:solidFill>
-              <a:srgbClr val="9A9A9F"/>
-            </a:solidFill>
-            <a:prstDash val="solid"/>
-            <a:tailEnd type="triangle" w="med" len="med"/>
-          </a:ln>
-        </p:spPr>
-      </p:cxnSp>
-      <p:cxnSp>
-        <p:nvCxnSpPr>
-          <p:cNvPr id="682" name=""/>
-          <p:cNvCxnSpPr>
-            <a:stCxn xmlns:a="http://schemas.openxmlformats.org/drawingml/2006/main" id="7" idx="3"/>
-            <a:endCxn xmlns:a="http://schemas.openxmlformats.org/drawingml/2006/main" id="11" idx="1"/>
-          </p:cNvCxnSpPr>
-          <p:nvPr/>
-        </p:nvCxnSpPr>
-        <p:spPr>
-          <a:xfrm xmlns:a="http://schemas.openxmlformats.org/drawingml/2006/main">
-            <a:off x="6057900" y="4219575"/>
-            <a:ext cx="571500" cy="0"/>
-          </a:xfrm>
-          <a:prstGeom xmlns:a="http://schemas.openxmlformats.org/drawingml/2006/main" prst="straightConnector1">
-            <a:avLst/>
-          </a:prstGeom>
-          <a:ln xmlns:a="http://schemas.openxmlformats.org/drawingml/2006/main" w="28575">
-            <a:solidFill>
-              <a:srgbClr val="9A9A9F"/>
-            </a:solidFill>
-            <a:prstDash val="solid"/>
-            <a:tailEnd type="triangle" w="med" len="med"/>
-          </a:ln>
-        </p:spPr>
-      </p:cxnSp>
-      <p:cxnSp>
-        <p:nvCxnSpPr>
-          <p:cNvPr id="683" name=""/>
-          <p:cNvCxnSpPr>
-            <a:stCxn xmlns:a="http://schemas.openxmlformats.org/drawingml/2006/main" id="11" idx="3"/>
-            <a:endCxn xmlns:a="http://schemas.openxmlformats.org/drawingml/2006/main" id="15" idx="1"/>
-          </p:cNvCxnSpPr>
-          <p:nvPr/>
-        </p:nvCxnSpPr>
-        <p:spPr>
-          <a:xfrm xmlns:a="http://schemas.openxmlformats.org/drawingml/2006/main">
-            <a:off x="8877300" y="4219575"/>
-            <a:ext cx="571500" cy="0"/>
-          </a:xfrm>
-          <a:prstGeom xmlns:a="http://schemas.openxmlformats.org/drawingml/2006/main" prst="straightConnector1">
-            <a:avLst/>
-          </a:prstGeom>
-          <a:ln xmlns:a="http://schemas.openxmlformats.org/drawingml/2006/main" w="28575">
-            <a:solidFill>
-              <a:srgbClr val="9A9A9F"/>
-            </a:solidFill>
-            <a:prstDash val="solid"/>
-            <a:tailEnd type="triangle" w="med" len="med"/>
-          </a:ln>
-        </p:spPr>
-      </p:cxnSp>
-      <p:cxnSp>
-        <p:nvCxnSpPr>
-          <p:cNvPr id="684" name=""/>
-          <p:cNvCxnSpPr>
-            <a:stCxn xmlns:a="http://schemas.openxmlformats.org/drawingml/2006/main" id="15" idx="3"/>
-            <a:endCxn xmlns:a="http://schemas.openxmlformats.org/drawingml/2006/main" id="19" idx="1"/>
-          </p:cNvCxnSpPr>
-          <p:nvPr/>
-        </p:nvCxnSpPr>
-        <p:spPr>
-          <a:xfrm xmlns:a="http://schemas.openxmlformats.org/drawingml/2006/main">
-            <a:off x="11696700" y="4219575"/>
-            <a:ext cx="571500" cy="0"/>
-          </a:xfrm>
-          <a:prstGeom xmlns:a="http://schemas.openxmlformats.org/drawingml/2006/main" prst="straightConnector1">
-            <a:avLst/>
-          </a:prstGeom>
-          <a:ln xmlns:a="http://schemas.openxmlformats.org/drawingml/2006/main" w="28575">
-            <a:solidFill>
-              <a:srgbClr val="9A9A9F"/>
-            </a:solidFill>
-            <a:prstDash val="solid"/>
-            <a:tailEnd type="triangle" w="med" len="med"/>
-          </a:ln>
-        </p:spPr>
-      </p:cxnSp>
-      <p:sp>
-        <p:nvSpPr>
-          <p:cNvPr id="27" name="">
-            <a:extLst xmlns:a="http://schemas.openxmlformats.org/drawingml/2006/main">
-              <a:ext uri="{FF2B5EF4-FFF2-40B4-BE49-F238E27FC236}">
-                <a16:creationId xmlns:a16="http://schemas.microsoft.com/office/drawing/2014/main" id="{79128475-820B-447C-A724-7D8A31328FFE}"/>
-              </a:ext>
-            </a:extLst>
-          </p:cNvPr>
-          <p:cNvSpPr>
-            <a:spLocks xmlns:a="http://schemas.openxmlformats.org/drawingml/2006/main" noGrp="1"/>
-          </p:cNvSpPr>
-          <p:nvPr/>
-        </p:nvSpPr>
-        <p:spPr>
-          <a:xfrm xmlns:a="http://schemas.openxmlformats.org/drawingml/2006/main">
-            <a:off x="2381250" y="6210300"/>
-            <a:ext cx="10477500" cy="457200"/>
-          </a:xfrm>
-          <a:prstGeom xmlns:a="http://schemas.openxmlformats.org/drawingml/2006/main" prst="rect">
-            <a:avLst/>
-          </a:prstGeom>
-          <a:noFill xmlns:a="http://schemas.openxmlformats.org/drawingml/2006/main"/>
-          <a:ln xmlns:a="http://schemas.openxmlformats.org/drawingml/2006/main" w="0">
-            <a:noFill/>
-            <a:prstDash val="solid"/>
-          </a:ln>
-        </p:spPr>
-        <p:txBody>
-          <a:bodyPr xmlns:a="http://schemas.openxmlformats.org/drawingml/2006/main" wrap="square" lIns="0" tIns="0" rIns="0" bIns="0" anchor="ctr">
-            <a:normAutofit fontScale="100000"/>
-          </a:bodyPr>
-          <a:lstStyle xmlns:a="http://schemas.openxmlformats.org/drawingml/2006/main"/>
-          <a:p xmlns:a="http://schemas.openxmlformats.org/drawingml/2006/main">
-            <a:pPr algn="ctr">
-              <a:lnSpc>
-                <a:spcPct val="100000"/>
-              </a:lnSpc>
-              <a:buNone/>
-              <a:defRPr sz="2100" b="1">
-                <a:solidFill>
-                  <a:srgbClr val="051C2A"/>
-                </a:solidFill>
-                <a:latin typeface="Calibri"/>
-                <a:ea typeface="Calibri"/>
-                <a:cs typeface="Calibri"/>
-              </a:defRPr>
-            </a:pPr>
-            <a:r>
-              <a:rPr sz="2100" b="1">
-                <a:solidFill>
-                  <a:srgbClr val="051C2A"/>
-                </a:solidFill>
-                <a:latin typeface="Calibri"/>
-                <a:ea typeface="Calibri"/>
-                <a:cs typeface="Calibri"/>
-              </a:rPr>
-              <a:t>The typed error stays visible between TOOL and replan.</a:t>
-            </a:r>
-          </a:p>
-        </p:txBody>
-      </p:sp>
-      <p:sp>
-        <p:nvSpPr>
-          <p:cNvPr id="28" name="">
-            <a:extLst xmlns:a="http://schemas.openxmlformats.org/drawingml/2006/main">
-              <a:ext uri="{FF2B5EF4-FFF2-40B4-BE49-F238E27FC236}">
-                <a16:creationId xmlns:a16="http://schemas.microsoft.com/office/drawing/2014/main" id="{685F2AAD-81FC-436A-88F7-89F49C9F1671}"/>
-              </a:ext>
-            </a:extLst>
-          </p:cNvPr>
-          <p:cNvSpPr>
-            <a:spLocks xmlns:a="http://schemas.openxmlformats.org/drawingml/2006/main" noGrp="1"/>
-          </p:cNvSpPr>
-          <p:nvPr/>
-        </p:nvSpPr>
-        <p:spPr>
-          <a:xfrm xmlns:a="http://schemas.openxmlformats.org/drawingml/2006/main">
-            <a:off x="1885950" y="6838950"/>
-            <a:ext cx="4476750" cy="323850"/>
-          </a:xfrm>
-          <a:prstGeom xmlns:a="http://schemas.openxmlformats.org/drawingml/2006/main" prst="rect">
-            <a:avLst/>
-          </a:prstGeom>
-          <a:noFill xmlns:a="http://schemas.openxmlformats.org/drawingml/2006/main"/>
-          <a:ln xmlns:a="http://schemas.openxmlformats.org/drawingml/2006/main" w="0">
-            <a:noFill/>
-            <a:prstDash val="solid"/>
-          </a:ln>
-        </p:spPr>
-        <p:txBody>
-          <a:bodyPr xmlns:a="http://schemas.openxmlformats.org/drawingml/2006/main" wrap="square" lIns="0" tIns="0" rIns="0" bIns="0" anchor="ctr">
-            <a:normAutofit fontScale="100000"/>
-          </a:bodyPr>
-          <a:lstStyle xmlns:a="http://schemas.openxmlformats.org/drawingml/2006/main"/>
-          <a:p xmlns:a="http://schemas.openxmlformats.org/drawingml/2006/main">
-            <a:pPr algn="ctr">
-              <a:lnSpc>
-                <a:spcPct val="100000"/>
-              </a:lnSpc>
-              <a:buNone/>
-              <a:defRPr sz="1500" b="0">
-                <a:solidFill>
-                  <a:srgbClr val="64748B"/>
-                </a:solidFill>
-                <a:latin typeface="Calibri"/>
-                <a:ea typeface="Calibri"/>
-                <a:cs typeface="Calibri"/>
-              </a:defRPr>
-            </a:pPr>
-            <a:r>
-              <a:rPr sz="1500" b="0">
-                <a:solidFill>
-                  <a:srgbClr val="64748B"/>
-                </a:solidFill>
-                <a:latin typeface="Calibri"/>
-                <a:ea typeface="Calibri"/>
-                <a:cs typeface="Calibri"/>
-              </a:rPr>
-              <a:t>public state</a:t>
-            </a:r>
-          </a:p>
-        </p:txBody>
-      </p:sp>
-      <p:sp>
-        <p:nvSpPr>
-          <p:cNvPr id="29" name="">
-            <a:extLst xmlns:a="http://schemas.openxmlformats.org/drawingml/2006/main">
-              <a:ext uri="{FF2B5EF4-FFF2-40B4-BE49-F238E27FC236}">
-                <a16:creationId xmlns:a16="http://schemas.microsoft.com/office/drawing/2014/main" id="{CDE04AD7-6CBE-4792-B549-765578FB3E1E}"/>
-              </a:ext>
-            </a:extLst>
-          </p:cNvPr>
-          <p:cNvSpPr>
-            <a:spLocks xmlns:a="http://schemas.openxmlformats.org/drawingml/2006/main" noGrp="1"/>
-          </p:cNvSpPr>
-          <p:nvPr/>
-        </p:nvSpPr>
-        <p:spPr>
-          <a:xfrm xmlns:a="http://schemas.openxmlformats.org/drawingml/2006/main">
-            <a:off x="8801100" y="6838950"/>
-            <a:ext cx="4762500" cy="323850"/>
-          </a:xfrm>
-          <a:prstGeom xmlns:a="http://schemas.openxmlformats.org/drawingml/2006/main" prst="rect">
-            <a:avLst/>
-          </a:prstGeom>
-          <a:noFill xmlns:a="http://schemas.openxmlformats.org/drawingml/2006/main"/>
-          <a:ln xmlns:a="http://schemas.openxmlformats.org/drawingml/2006/main" w="0">
-            <a:noFill/>
-            <a:prstDash val="solid"/>
-          </a:ln>
-        </p:spPr>
-        <p:txBody>
-          <a:bodyPr xmlns:a="http://schemas.openxmlformats.org/drawingml/2006/main" wrap="square" lIns="0" tIns="0" rIns="0" bIns="0" anchor="ctr">
-            <a:normAutofit fontScale="100000"/>
-          </a:bodyPr>
-          <a:lstStyle xmlns:a="http://schemas.openxmlformats.org/drawingml/2006/main"/>
-          <a:p xmlns:a="http://schemas.openxmlformats.org/drawingml/2006/main">
-            <a:pPr algn="ctr">
-              <a:lnSpc>
-                <a:spcPct val="100000"/>
-              </a:lnSpc>
-              <a:buNone/>
-              <a:defRPr sz="1500" b="0">
-                <a:solidFill>
-                  <a:srgbClr val="64748B"/>
-                </a:solidFill>
-                <a:latin typeface="Calibri"/>
-                <a:ea typeface="Calibri"/>
-                <a:cs typeface="Calibri"/>
-              </a:defRPr>
-            </a:pPr>
-            <a:r>
-              <a:rPr sz="1500" b="0">
-                <a:solidFill>
-                  <a:srgbClr val="64748B"/>
-                </a:solidFill>
-                <a:latin typeface="Calibri"/>
-                <a:ea typeface="Calibri"/>
-                <a:cs typeface="Calibri"/>
-              </a:rPr>
-              <a:t>one typed error</a:t>
-            </a:r>
-          </a:p>
-        </p:txBody>
-      </p:sp>
-      <p:sp>
-        <p:nvSpPr>
-          <p:cNvPr id="30" name="">
-            <a:extLst xmlns:a="http://schemas.openxmlformats.org/drawingml/2006/main">
-              <a:ext uri="{FF2B5EF4-FFF2-40B4-BE49-F238E27FC236}">
-                <a16:creationId xmlns:a16="http://schemas.microsoft.com/office/drawing/2014/main" id="{28CBA7AE-993C-4F84-A696-8D1323AC4E80}"/>
-              </a:ext>
-            </a:extLst>
-          </p:cNvPr>
-          <p:cNvSpPr>
-            <a:spLocks xmlns:a="http://schemas.openxmlformats.org/drawingml/2006/main" noGrp="1"/>
-          </p:cNvSpPr>
-          <p:nvPr/>
-        </p:nvSpPr>
-        <p:spPr>
-          <a:xfrm xmlns:a="http://schemas.openxmlformats.org/drawingml/2006/main">
-            <a:off x="857250" y="7896225"/>
-            <a:ext cx="13525500" cy="28575"/>
-          </a:xfrm>
-          <a:prstGeom xmlns:a="http://schemas.openxmlformats.org/drawingml/2006/main" prst="rect">
-            <a:avLst/>
-          </a:prstGeom>
-          <a:solidFill xmlns:a="http://schemas.openxmlformats.org/drawingml/2006/main">
-            <a:srgbClr val="E4E7E9"/>
-          </a:solidFill>
-          <a:ln xmlns:a="http://schemas.openxmlformats.org/drawingml/2006/main" w="0">
-            <a:solidFill>
-              <a:srgbClr val="E4E7E9"/>
-            </a:solidFill>
-            <a:prstDash val="solid"/>
-          </a:ln>
-        </p:spPr>
-      </p:sp>
-      <p:sp>
-        <p:nvSpPr>
-          <p:cNvPr id="31" name="">
-            <a:extLst xmlns:a="http://schemas.openxmlformats.org/drawingml/2006/main">
-              <a:ext uri="{FF2B5EF4-FFF2-40B4-BE49-F238E27FC236}">
-                <a16:creationId xmlns:a16="http://schemas.microsoft.com/office/drawing/2014/main" id="{DE97BF4D-EDBC-4480-A82B-512A72221950}"/>
-              </a:ext>
-            </a:extLst>
-          </p:cNvPr>
-          <p:cNvSpPr>
-            <a:spLocks xmlns:a="http://schemas.openxmlformats.org/drawingml/2006/main" noGrp="1"/>
-          </p:cNvSpPr>
-          <p:nvPr/>
-        </p:nvSpPr>
-        <p:spPr>
-          <a:xfrm xmlns:a="http://schemas.openxmlformats.org/drawingml/2006/main">
-            <a:off x="857250" y="7896225"/>
-            <a:ext cx="8001000" cy="38100"/>
-          </a:xfrm>
-          <a:prstGeom xmlns:a="http://schemas.openxmlformats.org/drawingml/2006/main" prst="rect">
-            <a:avLst/>
-          </a:prstGeom>
-          <a:solidFill xmlns:a="http://schemas.openxmlformats.org/drawingml/2006/main">
-            <a:srgbClr val="00A2EB"/>
-          </a:solidFill>
-          <a:ln xmlns:a="http://schemas.openxmlformats.org/drawingml/2006/main" w="0">
-            <a:solidFill>
-              <a:srgbClr val="00A2EB"/>
-            </a:solidFill>
-            <a:prstDash val="solid"/>
-          </a:ln>
-        </p:spPr>
-      </p:sp>
-      <p:sp>
-        <p:nvSpPr>
-          <p:cNvPr id="32" name="">
-            <a:extLst xmlns:a="http://schemas.openxmlformats.org/drawingml/2006/main">
-              <a:ext uri="{FF2B5EF4-FFF2-40B4-BE49-F238E27FC236}">
-                <a16:creationId xmlns:a16="http://schemas.microsoft.com/office/drawing/2014/main" id="{49281B64-2F0F-4357-A085-C65451F28236}"/>
-              </a:ext>
-            </a:extLst>
-          </p:cNvPr>
-          <p:cNvSpPr>
-            <a:spLocks xmlns:a="http://schemas.openxmlformats.org/drawingml/2006/main" noGrp="1"/>
-          </p:cNvSpPr>
-          <p:nvPr/>
-        </p:nvSpPr>
-        <p:spPr>
-          <a:xfrm xmlns:a="http://schemas.openxmlformats.org/drawingml/2006/main">
-            <a:off x="971550" y="8058150"/>
-            <a:ext cx="3714750" cy="323850"/>
-          </a:xfrm>
-          <a:prstGeom xmlns:a="http://schemas.openxmlformats.org/drawingml/2006/main" prst="rect">
-            <a:avLst/>
-          </a:prstGeom>
-          <a:noFill xmlns:a="http://schemas.openxmlformats.org/drawingml/2006/main"/>
-          <a:ln xmlns:a="http://schemas.openxmlformats.org/drawingml/2006/main" w="0">
-            <a:noFill/>
-            <a:prstDash val="solid"/>
-          </a:ln>
-        </p:spPr>
-        <p:txBody>
-          <a:bodyPr xmlns:a="http://schemas.openxmlformats.org/drawingml/2006/main" wrap="square" lIns="0" tIns="0" rIns="0" bIns="0" anchor="ctr">
-            <a:normAutofit fontScale="100000"/>
-          </a:bodyPr>
-          <a:lstStyle xmlns:a="http://schemas.openxmlformats.org/drawingml/2006/main"/>
-          <a:p xmlns:a="http://schemas.openxmlformats.org/drawingml/2006/main">
-            <a:pPr algn="l">
-              <a:lnSpc>
-                <a:spcPct val="100000"/>
-              </a:lnSpc>
-              <a:buNone/>
-              <a:defRPr sz="1200" b="0">
-                <a:solidFill>
                   <a:srgbClr val="9A9A9F"/>
                 </a:solidFill>
                 <a:latin typeface="Calibri"/>
@@ -10019,6 +8810,1613 @@
           </a:p>
         </p:txBody>
       </p:sp>
+      <p:sp>
+        <p:nvSpPr>
+          <p:cNvPr id="36" name="trace-stage-1">
+            <a:extLst xmlns:a="http://schemas.openxmlformats.org/drawingml/2006/main">
+              <a:ext uri="{FF2B5EF4-FFF2-40B4-BE49-F238E27FC236}">
+                <a16:creationId xmlns:a16="http://schemas.microsoft.com/office/drawing/2014/main" id="{EA7513CE-170F-4519-B383-AF1A0926F87F}"/>
+              </a:ext>
+            </a:extLst>
+          </p:cNvPr>
+          <p:cNvSpPr>
+            <a:spLocks xmlns:a="http://schemas.openxmlformats.org/drawingml/2006/main" noGrp="1"/>
+          </p:cNvSpPr>
+          <p:nvPr/>
+        </p:nvSpPr>
+        <p:spPr>
+          <a:xfrm xmlns:a="http://schemas.openxmlformats.org/drawingml/2006/main">
+            <a:off x="990600" y="3048000"/>
+            <a:ext cx="1771650" cy="2286000"/>
+          </a:xfrm>
+          <a:prstGeom xmlns:a="http://schemas.openxmlformats.org/drawingml/2006/main" prst="roundRect">
+            <a:avLst>
+              <a:gd name="adj" fmla="val 6452"/>
+            </a:avLst>
+          </a:prstGeom>
+          <a:noFill xmlns:a="http://schemas.openxmlformats.org/drawingml/2006/main"/>
+          <a:ln xmlns:a="http://schemas.openxmlformats.org/drawingml/2006/main" w="9525">
+            <a:solidFill>
+              <a:srgbClr val="E4E7E9"/>
+            </a:solidFill>
+            <a:prstDash val="solid"/>
+          </a:ln>
+        </p:spPr>
+      </p:sp>
+      <p:sp>
+        <p:nvSpPr>
+          <p:cNvPr id="37" name="trace-stage-1-step">
+            <a:extLst xmlns:a="http://schemas.openxmlformats.org/drawingml/2006/main">
+              <a:ext uri="{FF2B5EF4-FFF2-40B4-BE49-F238E27FC236}">
+                <a16:creationId xmlns:a16="http://schemas.microsoft.com/office/drawing/2014/main" id="{67D7FEA0-BD75-4BAE-803A-210231C3B54C}"/>
+              </a:ext>
+            </a:extLst>
+          </p:cNvPr>
+          <p:cNvSpPr>
+            <a:spLocks xmlns:a="http://schemas.openxmlformats.org/drawingml/2006/main" noGrp="1"/>
+          </p:cNvSpPr>
+          <p:nvPr/>
+        </p:nvSpPr>
+        <p:spPr>
+          <a:xfrm xmlns:a="http://schemas.openxmlformats.org/drawingml/2006/main">
+            <a:off x="1162050" y="3238500"/>
+            <a:ext cx="533400" cy="285750"/>
+          </a:xfrm>
+          <a:prstGeom xmlns:a="http://schemas.openxmlformats.org/drawingml/2006/main" prst="rect">
+            <a:avLst/>
+          </a:prstGeom>
+          <a:noFill xmlns:a="http://schemas.openxmlformats.org/drawingml/2006/main"/>
+          <a:ln xmlns:a="http://schemas.openxmlformats.org/drawingml/2006/main" w="0">
+            <a:noFill/>
+            <a:prstDash val="solid"/>
+          </a:ln>
+        </p:spPr>
+        <p:txBody>
+          <a:bodyPr xmlns:a="http://schemas.openxmlformats.org/drawingml/2006/main"/>
+          <a:lstStyle xmlns:a="http://schemas.openxmlformats.org/drawingml/2006/main"/>
+          <a:p xmlns:a="http://schemas.openxmlformats.org/drawingml/2006/main">
+            <a:pPr>
+              <a:defRPr sz="1500" b="1">
+                <a:solidFill>
+                  <a:srgbClr val="00A2EB"/>
+                </a:solidFill>
+              </a:defRPr>
+            </a:pPr>
+            <a:r>
+              <a:rPr sz="1500" b="1">
+                <a:solidFill>
+                  <a:srgbClr val="00A2EB"/>
+                </a:solidFill>
+              </a:rPr>
+              <a:t>01</a:t>
+            </a:r>
+          </a:p>
+        </p:txBody>
+      </p:sp>
+      <p:sp>
+        <p:nvSpPr>
+          <p:cNvPr id="38" name="trace-stage-1-title">
+            <a:extLst xmlns:a="http://schemas.openxmlformats.org/drawingml/2006/main">
+              <a:ext uri="{FF2B5EF4-FFF2-40B4-BE49-F238E27FC236}">
+                <a16:creationId xmlns:a16="http://schemas.microsoft.com/office/drawing/2014/main" id="{F46221E3-E20E-4ED8-B523-2716C9BAD7E0}"/>
+              </a:ext>
+            </a:extLst>
+          </p:cNvPr>
+          <p:cNvSpPr>
+            <a:spLocks xmlns:a="http://schemas.openxmlformats.org/drawingml/2006/main" noGrp="1"/>
+          </p:cNvSpPr>
+          <p:nvPr/>
+        </p:nvSpPr>
+        <p:spPr>
+          <a:xfrm xmlns:a="http://schemas.openxmlformats.org/drawingml/2006/main">
+            <a:off x="1104900" y="3733800"/>
+            <a:ext cx="1543050" cy="590550"/>
+          </a:xfrm>
+          <a:prstGeom xmlns:a="http://schemas.openxmlformats.org/drawingml/2006/main" prst="rect">
+            <a:avLst/>
+          </a:prstGeom>
+          <a:noFill xmlns:a="http://schemas.openxmlformats.org/drawingml/2006/main"/>
+          <a:ln xmlns:a="http://schemas.openxmlformats.org/drawingml/2006/main" w="0">
+            <a:noFill/>
+            <a:prstDash val="solid"/>
+          </a:ln>
+        </p:spPr>
+        <p:txBody>
+          <a:bodyPr xmlns:a="http://schemas.openxmlformats.org/drawingml/2006/main"/>
+          <a:lstStyle xmlns:a="http://schemas.openxmlformats.org/drawingml/2006/main"/>
+          <a:p xmlns:a="http://schemas.openxmlformats.org/drawingml/2006/main">
+            <a:pPr algn="ctr">
+              <a:defRPr sz="1575" b="1">
+                <a:solidFill>
+                  <a:srgbClr val="0A2030"/>
+                </a:solidFill>
+              </a:defRPr>
+            </a:pPr>
+            <a:r>
+              <a:rPr sz="1575" b="1">
+                <a:solidFill>
+                  <a:srgbClr val="0A2030"/>
+                </a:solidFill>
+              </a:rPr>
+              <a:t>PLAN</a:t>
+            </a:r>
+          </a:p>
+        </p:txBody>
+      </p:sp>
+      <p:sp>
+        <p:nvSpPr>
+          <p:cNvPr id="39" name="trace-stage-1-body">
+            <a:extLst xmlns:a="http://schemas.openxmlformats.org/drawingml/2006/main">
+              <a:ext uri="{FF2B5EF4-FFF2-40B4-BE49-F238E27FC236}">
+                <a16:creationId xmlns:a16="http://schemas.microsoft.com/office/drawing/2014/main" id="{D1B29EEE-C8B0-4827-BFFE-35C898FB7054}"/>
+              </a:ext>
+            </a:extLst>
+          </p:cNvPr>
+          <p:cNvSpPr>
+            <a:spLocks xmlns:a="http://schemas.openxmlformats.org/drawingml/2006/main" noGrp="1"/>
+          </p:cNvSpPr>
+          <p:nvPr/>
+        </p:nvSpPr>
+        <p:spPr>
+          <a:xfrm xmlns:a="http://schemas.openxmlformats.org/drawingml/2006/main">
+            <a:off x="1028700" y="4533900"/>
+            <a:ext cx="1695450" cy="552450"/>
+          </a:xfrm>
+          <a:prstGeom xmlns:a="http://schemas.openxmlformats.org/drawingml/2006/main" prst="rect">
+            <a:avLst/>
+          </a:prstGeom>
+          <a:noFill xmlns:a="http://schemas.openxmlformats.org/drawingml/2006/main"/>
+          <a:ln xmlns:a="http://schemas.openxmlformats.org/drawingml/2006/main" w="0">
+            <a:noFill/>
+            <a:prstDash val="solid"/>
+          </a:ln>
+        </p:spPr>
+        <p:txBody>
+          <a:bodyPr xmlns:a="http://schemas.openxmlformats.org/drawingml/2006/main"/>
+          <a:lstStyle xmlns:a="http://schemas.openxmlformats.org/drawingml/2006/main"/>
+          <a:p xmlns:a="http://schemas.openxmlformats.org/drawingml/2006/main">
+            <a:pPr algn="ctr">
+              <a:defRPr sz="1200" b="0">
+                <a:solidFill>
+                  <a:srgbClr val="1F40CB"/>
+                </a:solidFill>
+              </a:defRPr>
+            </a:pPr>
+            <a:r>
+              <a:rPr sz="1200" b="0">
+                <a:solidFill>
+                  <a:srgbClr val="1F40CB"/>
+                </a:solidFill>
+              </a:rPr>
+              <a:t>mission +</a:t>
+            </a:r>
+          </a:p>
+          <a:p xmlns:a="http://schemas.openxmlformats.org/drawingml/2006/main">
+            <a:pPr algn="ctr">
+              <a:defRPr sz="1200" b="0">
+                <a:solidFill>
+                  <a:srgbClr val="1F40CB"/>
+                </a:solidFill>
+              </a:defRPr>
+            </a:pPr>
+            <a:r>
+              <a:rPr sz="1200" b="0">
+                <a:solidFill>
+                  <a:srgbClr val="1F40CB"/>
+                </a:solidFill>
+              </a:rPr>
+              <a:t>typed steps</a:t>
+            </a:r>
+          </a:p>
+        </p:txBody>
+      </p:sp>
+      <p:sp>
+        <p:nvSpPr>
+          <p:cNvPr id="40" name="trace-stage-2">
+            <a:extLst xmlns:a="http://schemas.openxmlformats.org/drawingml/2006/main">
+              <a:ext uri="{FF2B5EF4-FFF2-40B4-BE49-F238E27FC236}">
+                <a16:creationId xmlns:a16="http://schemas.microsoft.com/office/drawing/2014/main" id="{65B12F75-F768-4BE1-9084-C180190E3827}"/>
+              </a:ext>
+            </a:extLst>
+          </p:cNvPr>
+          <p:cNvSpPr>
+            <a:spLocks xmlns:a="http://schemas.openxmlformats.org/drawingml/2006/main" noGrp="1"/>
+          </p:cNvSpPr>
+          <p:nvPr/>
+        </p:nvSpPr>
+        <p:spPr>
+          <a:xfrm xmlns:a="http://schemas.openxmlformats.org/drawingml/2006/main">
+            <a:off x="2943225" y="3048000"/>
+            <a:ext cx="1771650" cy="2286000"/>
+          </a:xfrm>
+          <a:prstGeom xmlns:a="http://schemas.openxmlformats.org/drawingml/2006/main" prst="roundRect">
+            <a:avLst>
+              <a:gd name="adj" fmla="val 6452"/>
+            </a:avLst>
+          </a:prstGeom>
+          <a:noFill xmlns:a="http://schemas.openxmlformats.org/drawingml/2006/main"/>
+          <a:ln xmlns:a="http://schemas.openxmlformats.org/drawingml/2006/main" w="9525">
+            <a:solidFill>
+              <a:srgbClr val="E4E7E9"/>
+            </a:solidFill>
+            <a:prstDash val="solid"/>
+          </a:ln>
+        </p:spPr>
+      </p:sp>
+      <p:sp>
+        <p:nvSpPr>
+          <p:cNvPr id="41" name="trace-stage-2-step">
+            <a:extLst xmlns:a="http://schemas.openxmlformats.org/drawingml/2006/main">
+              <a:ext uri="{FF2B5EF4-FFF2-40B4-BE49-F238E27FC236}">
+                <a16:creationId xmlns:a16="http://schemas.microsoft.com/office/drawing/2014/main" id="{63D6C81A-FC0E-4E18-B82B-7DC9F9B4A594}"/>
+              </a:ext>
+            </a:extLst>
+          </p:cNvPr>
+          <p:cNvSpPr>
+            <a:spLocks xmlns:a="http://schemas.openxmlformats.org/drawingml/2006/main" noGrp="1"/>
+          </p:cNvSpPr>
+          <p:nvPr/>
+        </p:nvSpPr>
+        <p:spPr>
+          <a:xfrm xmlns:a="http://schemas.openxmlformats.org/drawingml/2006/main">
+            <a:off x="3114675" y="3238500"/>
+            <a:ext cx="533400" cy="285750"/>
+          </a:xfrm>
+          <a:prstGeom xmlns:a="http://schemas.openxmlformats.org/drawingml/2006/main" prst="rect">
+            <a:avLst/>
+          </a:prstGeom>
+          <a:noFill xmlns:a="http://schemas.openxmlformats.org/drawingml/2006/main"/>
+          <a:ln xmlns:a="http://schemas.openxmlformats.org/drawingml/2006/main" w="0">
+            <a:noFill/>
+            <a:prstDash val="solid"/>
+          </a:ln>
+        </p:spPr>
+        <p:txBody>
+          <a:bodyPr xmlns:a="http://schemas.openxmlformats.org/drawingml/2006/main"/>
+          <a:lstStyle xmlns:a="http://schemas.openxmlformats.org/drawingml/2006/main"/>
+          <a:p xmlns:a="http://schemas.openxmlformats.org/drawingml/2006/main">
+            <a:pPr>
+              <a:defRPr sz="1500" b="1">
+                <a:solidFill>
+                  <a:srgbClr val="00A2EB"/>
+                </a:solidFill>
+              </a:defRPr>
+            </a:pPr>
+            <a:r>
+              <a:rPr sz="1500" b="1">
+                <a:solidFill>
+                  <a:srgbClr val="00A2EB"/>
+                </a:solidFill>
+              </a:rPr>
+              <a:t>02</a:t>
+            </a:r>
+          </a:p>
+        </p:txBody>
+      </p:sp>
+      <p:sp>
+        <p:nvSpPr>
+          <p:cNvPr id="42" name="trace-stage-2-title">
+            <a:extLst xmlns:a="http://schemas.openxmlformats.org/drawingml/2006/main">
+              <a:ext uri="{FF2B5EF4-FFF2-40B4-BE49-F238E27FC236}">
+                <a16:creationId xmlns:a16="http://schemas.microsoft.com/office/drawing/2014/main" id="{07FF58E4-B114-4034-B0EF-B2F909BB2F23}"/>
+              </a:ext>
+            </a:extLst>
+          </p:cNvPr>
+          <p:cNvSpPr>
+            <a:spLocks xmlns:a="http://schemas.openxmlformats.org/drawingml/2006/main" noGrp="1"/>
+          </p:cNvSpPr>
+          <p:nvPr/>
+        </p:nvSpPr>
+        <p:spPr>
+          <a:xfrm xmlns:a="http://schemas.openxmlformats.org/drawingml/2006/main">
+            <a:off x="3057525" y="3733800"/>
+            <a:ext cx="1543050" cy="590550"/>
+          </a:xfrm>
+          <a:prstGeom xmlns:a="http://schemas.openxmlformats.org/drawingml/2006/main" prst="rect">
+            <a:avLst/>
+          </a:prstGeom>
+          <a:noFill xmlns:a="http://schemas.openxmlformats.org/drawingml/2006/main"/>
+          <a:ln xmlns:a="http://schemas.openxmlformats.org/drawingml/2006/main" w="0">
+            <a:noFill/>
+            <a:prstDash val="solid"/>
+          </a:ln>
+        </p:spPr>
+        <p:txBody>
+          <a:bodyPr xmlns:a="http://schemas.openxmlformats.org/drawingml/2006/main"/>
+          <a:lstStyle xmlns:a="http://schemas.openxmlformats.org/drawingml/2006/main"/>
+          <a:p xmlns:a="http://schemas.openxmlformats.org/drawingml/2006/main">
+            <a:pPr algn="ctr">
+              <a:defRPr sz="1575" b="1">
+                <a:solidFill>
+                  <a:srgbClr val="0A2030"/>
+                </a:solidFill>
+              </a:defRPr>
+            </a:pPr>
+            <a:r>
+              <a:rPr sz="1575" b="1">
+                <a:solidFill>
+                  <a:srgbClr val="0A2030"/>
+                </a:solidFill>
+              </a:rPr>
+              <a:t>PLAN GATE</a:t>
+            </a:r>
+          </a:p>
+        </p:txBody>
+      </p:sp>
+      <p:sp>
+        <p:nvSpPr>
+          <p:cNvPr id="43" name="trace-stage-2-body">
+            <a:extLst xmlns:a="http://schemas.openxmlformats.org/drawingml/2006/main">
+              <a:ext uri="{FF2B5EF4-FFF2-40B4-BE49-F238E27FC236}">
+                <a16:creationId xmlns:a16="http://schemas.microsoft.com/office/drawing/2014/main" id="{F8D56BB3-49F3-4446-BF77-B669E57FBBCA}"/>
+              </a:ext>
+            </a:extLst>
+          </p:cNvPr>
+          <p:cNvSpPr>
+            <a:spLocks xmlns:a="http://schemas.openxmlformats.org/drawingml/2006/main" noGrp="1"/>
+          </p:cNvSpPr>
+          <p:nvPr/>
+        </p:nvSpPr>
+        <p:spPr>
+          <a:xfrm xmlns:a="http://schemas.openxmlformats.org/drawingml/2006/main">
+            <a:off x="2981325" y="4533900"/>
+            <a:ext cx="1695450" cy="552450"/>
+          </a:xfrm>
+          <a:prstGeom xmlns:a="http://schemas.openxmlformats.org/drawingml/2006/main" prst="rect">
+            <a:avLst/>
+          </a:prstGeom>
+          <a:noFill xmlns:a="http://schemas.openxmlformats.org/drawingml/2006/main"/>
+          <a:ln xmlns:a="http://schemas.openxmlformats.org/drawingml/2006/main" w="0">
+            <a:noFill/>
+            <a:prstDash val="solid"/>
+          </a:ln>
+        </p:spPr>
+        <p:txBody>
+          <a:bodyPr xmlns:a="http://schemas.openxmlformats.org/drawingml/2006/main"/>
+          <a:lstStyle xmlns:a="http://schemas.openxmlformats.org/drawingml/2006/main"/>
+          <a:p xmlns:a="http://schemas.openxmlformats.org/drawingml/2006/main">
+            <a:pPr algn="ctr">
+              <a:defRPr sz="1200" b="0">
+                <a:solidFill>
+                  <a:srgbClr val="1F40CB"/>
+                </a:solidFill>
+              </a:defRPr>
+            </a:pPr>
+            <a:r>
+              <a:rPr sz="1200" b="0">
+                <a:solidFill>
+                  <a:srgbClr val="1F40CB"/>
+                </a:solidFill>
+              </a:rPr>
+              <a:t>schema +</a:t>
+            </a:r>
+          </a:p>
+          <a:p xmlns:a="http://schemas.openxmlformats.org/drawingml/2006/main">
+            <a:pPr algn="ctr">
+              <a:defRPr sz="1200" b="0">
+                <a:solidFill>
+                  <a:srgbClr val="1F40CB"/>
+                </a:solidFill>
+              </a:defRPr>
+            </a:pPr>
+            <a:r>
+              <a:rPr sz="1200" b="0">
+                <a:solidFill>
+                  <a:srgbClr val="1F40CB"/>
+                </a:solidFill>
+              </a:rPr>
+              <a:t>budget</a:t>
+            </a:r>
+          </a:p>
+        </p:txBody>
+      </p:sp>
+      <p:sp>
+        <p:nvSpPr>
+          <p:cNvPr id="44" name="trace-stage-3">
+            <a:extLst xmlns:a="http://schemas.openxmlformats.org/drawingml/2006/main">
+              <a:ext uri="{FF2B5EF4-FFF2-40B4-BE49-F238E27FC236}">
+                <a16:creationId xmlns:a16="http://schemas.microsoft.com/office/drawing/2014/main" id="{338B1008-D419-4DB3-9570-40EC9F703C4E}"/>
+              </a:ext>
+            </a:extLst>
+          </p:cNvPr>
+          <p:cNvSpPr>
+            <a:spLocks xmlns:a="http://schemas.openxmlformats.org/drawingml/2006/main" noGrp="1"/>
+          </p:cNvSpPr>
+          <p:nvPr/>
+        </p:nvSpPr>
+        <p:spPr>
+          <a:xfrm xmlns:a="http://schemas.openxmlformats.org/drawingml/2006/main">
+            <a:off x="4895850" y="3048000"/>
+            <a:ext cx="1771650" cy="2286000"/>
+          </a:xfrm>
+          <a:prstGeom xmlns:a="http://schemas.openxmlformats.org/drawingml/2006/main" prst="roundRect">
+            <a:avLst>
+              <a:gd name="adj" fmla="val 6452"/>
+            </a:avLst>
+          </a:prstGeom>
+          <a:noFill xmlns:a="http://schemas.openxmlformats.org/drawingml/2006/main"/>
+          <a:ln xmlns:a="http://schemas.openxmlformats.org/drawingml/2006/main" w="19050">
+            <a:solidFill>
+              <a:srgbClr val="051C2A"/>
+            </a:solidFill>
+            <a:prstDash val="solid"/>
+          </a:ln>
+        </p:spPr>
+      </p:sp>
+      <p:sp>
+        <p:nvSpPr>
+          <p:cNvPr id="45" name="trace-stage-3-step">
+            <a:extLst xmlns:a="http://schemas.openxmlformats.org/drawingml/2006/main">
+              <a:ext uri="{FF2B5EF4-FFF2-40B4-BE49-F238E27FC236}">
+                <a16:creationId xmlns:a16="http://schemas.microsoft.com/office/drawing/2014/main" id="{900A3379-3E75-4D8E-A6DE-9540E7365D2F}"/>
+              </a:ext>
+            </a:extLst>
+          </p:cNvPr>
+          <p:cNvSpPr>
+            <a:spLocks xmlns:a="http://schemas.openxmlformats.org/drawingml/2006/main" noGrp="1"/>
+          </p:cNvSpPr>
+          <p:nvPr/>
+        </p:nvSpPr>
+        <p:spPr>
+          <a:xfrm xmlns:a="http://schemas.openxmlformats.org/drawingml/2006/main">
+            <a:off x="5067300" y="3238500"/>
+            <a:ext cx="533400" cy="285750"/>
+          </a:xfrm>
+          <a:prstGeom xmlns:a="http://schemas.openxmlformats.org/drawingml/2006/main" prst="rect">
+            <a:avLst/>
+          </a:prstGeom>
+          <a:noFill xmlns:a="http://schemas.openxmlformats.org/drawingml/2006/main"/>
+          <a:ln xmlns:a="http://schemas.openxmlformats.org/drawingml/2006/main" w="0">
+            <a:noFill/>
+            <a:prstDash val="solid"/>
+          </a:ln>
+        </p:spPr>
+        <p:txBody>
+          <a:bodyPr xmlns:a="http://schemas.openxmlformats.org/drawingml/2006/main"/>
+          <a:lstStyle xmlns:a="http://schemas.openxmlformats.org/drawingml/2006/main"/>
+          <a:p xmlns:a="http://schemas.openxmlformats.org/drawingml/2006/main">
+            <a:pPr>
+              <a:defRPr sz="1500" b="1">
+                <a:solidFill>
+                  <a:srgbClr val="00A2EB"/>
+                </a:solidFill>
+              </a:defRPr>
+            </a:pPr>
+            <a:r>
+              <a:rPr sz="1500" b="1">
+                <a:solidFill>
+                  <a:srgbClr val="00A2EB"/>
+                </a:solidFill>
+              </a:rPr>
+              <a:t>03</a:t>
+            </a:r>
+          </a:p>
+        </p:txBody>
+      </p:sp>
+      <p:sp>
+        <p:nvSpPr>
+          <p:cNvPr id="46" name="trace-stage-3-title">
+            <a:extLst xmlns:a="http://schemas.openxmlformats.org/drawingml/2006/main">
+              <a:ext uri="{FF2B5EF4-FFF2-40B4-BE49-F238E27FC236}">
+                <a16:creationId xmlns:a16="http://schemas.microsoft.com/office/drawing/2014/main" id="{E9F01598-46EE-4682-BBA2-2356503767C7}"/>
+              </a:ext>
+            </a:extLst>
+          </p:cNvPr>
+          <p:cNvSpPr>
+            <a:spLocks xmlns:a="http://schemas.openxmlformats.org/drawingml/2006/main" noGrp="1"/>
+          </p:cNvSpPr>
+          <p:nvPr/>
+        </p:nvSpPr>
+        <p:spPr>
+          <a:xfrm xmlns:a="http://schemas.openxmlformats.org/drawingml/2006/main">
+            <a:off x="5010150" y="3733800"/>
+            <a:ext cx="1543050" cy="590550"/>
+          </a:xfrm>
+          <a:prstGeom xmlns:a="http://schemas.openxmlformats.org/drawingml/2006/main" prst="rect">
+            <a:avLst/>
+          </a:prstGeom>
+          <a:noFill xmlns:a="http://schemas.openxmlformats.org/drawingml/2006/main"/>
+          <a:ln xmlns:a="http://schemas.openxmlformats.org/drawingml/2006/main" w="0">
+            <a:noFill/>
+            <a:prstDash val="solid"/>
+          </a:ln>
+        </p:spPr>
+        <p:txBody>
+          <a:bodyPr xmlns:a="http://schemas.openxmlformats.org/drawingml/2006/main"/>
+          <a:lstStyle xmlns:a="http://schemas.openxmlformats.org/drawingml/2006/main"/>
+          <a:p xmlns:a="http://schemas.openxmlformats.org/drawingml/2006/main">
+            <a:pPr algn="ctr">
+              <a:defRPr sz="1575" b="1">
+                <a:solidFill>
+                  <a:srgbClr val="0A2030"/>
+                </a:solidFill>
+              </a:defRPr>
+            </a:pPr>
+            <a:r>
+              <a:rPr sz="1575" b="1">
+                <a:solidFill>
+                  <a:srgbClr val="0A2030"/>
+                </a:solidFill>
+              </a:rPr>
+              <a:t>TOOL</a:t>
+            </a:r>
+          </a:p>
+          <a:p xmlns:a="http://schemas.openxmlformats.org/drawingml/2006/main">
+            <a:pPr algn="ctr">
+              <a:defRPr sz="1575" b="1">
+                <a:solidFill>
+                  <a:srgbClr val="0A2030"/>
+                </a:solidFill>
+              </a:defRPr>
+            </a:pPr>
+            <a:r>
+              <a:rPr sz="1575" b="1">
+                <a:solidFill>
+                  <a:srgbClr val="0A2030"/>
+                </a:solidFill>
+              </a:rPr>
+              <a:t>ATTEMPTS</a:t>
+            </a:r>
+          </a:p>
+        </p:txBody>
+      </p:sp>
+      <p:sp>
+        <p:nvSpPr>
+          <p:cNvPr id="47" name="trace-stage-3-body">
+            <a:extLst xmlns:a="http://schemas.openxmlformats.org/drawingml/2006/main">
+              <a:ext uri="{FF2B5EF4-FFF2-40B4-BE49-F238E27FC236}">
+                <a16:creationId xmlns:a16="http://schemas.microsoft.com/office/drawing/2014/main" id="{0563448A-43C5-4965-BC67-DFCE3D58FA23}"/>
+              </a:ext>
+            </a:extLst>
+          </p:cNvPr>
+          <p:cNvSpPr>
+            <a:spLocks xmlns:a="http://schemas.openxmlformats.org/drawingml/2006/main" noGrp="1"/>
+          </p:cNvSpPr>
+          <p:nvPr/>
+        </p:nvSpPr>
+        <p:spPr>
+          <a:xfrm xmlns:a="http://schemas.openxmlformats.org/drawingml/2006/main">
+            <a:off x="4933950" y="4533900"/>
+            <a:ext cx="1695450" cy="552450"/>
+          </a:xfrm>
+          <a:prstGeom xmlns:a="http://schemas.openxmlformats.org/drawingml/2006/main" prst="rect">
+            <a:avLst/>
+          </a:prstGeom>
+          <a:noFill xmlns:a="http://schemas.openxmlformats.org/drawingml/2006/main"/>
+          <a:ln xmlns:a="http://schemas.openxmlformats.org/drawingml/2006/main" w="0">
+            <a:noFill/>
+            <a:prstDash val="solid"/>
+          </a:ln>
+        </p:spPr>
+        <p:txBody>
+          <a:bodyPr xmlns:a="http://schemas.openxmlformats.org/drawingml/2006/main"/>
+          <a:lstStyle xmlns:a="http://schemas.openxmlformats.org/drawingml/2006/main"/>
+          <a:p xmlns:a="http://schemas.openxmlformats.org/drawingml/2006/main">
+            <a:pPr algn="ctr">
+              <a:defRPr sz="1200" b="0">
+                <a:solidFill>
+                  <a:srgbClr val="F07D00"/>
+                </a:solidFill>
+              </a:defRPr>
+            </a:pPr>
+            <a:r>
+              <a:rPr sz="1200" b="0">
+                <a:solidFill>
+                  <a:srgbClr val="F07D00"/>
+                </a:solidFill>
+              </a:rPr>
+              <a:t>attempts 1-3</a:t>
+            </a:r>
+          </a:p>
+          <a:p xmlns:a="http://schemas.openxmlformats.org/drawingml/2006/main">
+            <a:pPr algn="ctr">
+              <a:defRPr sz="1200" b="0">
+                <a:solidFill>
+                  <a:srgbClr val="F07D00"/>
+                </a:solidFill>
+              </a:defRPr>
+            </a:pPr>
+            <a:r>
+              <a:rPr sz="1200" b="0">
+                <a:solidFill>
+                  <a:srgbClr val="F07D00"/>
+                </a:solidFill>
+              </a:rPr>
+              <a:t>unsupported_metric</a:t>
+            </a:r>
+          </a:p>
+        </p:txBody>
+      </p:sp>
+      <p:sp>
+        <p:nvSpPr>
+          <p:cNvPr id="48" name="trace-stage-4">
+            <a:extLst xmlns:a="http://schemas.openxmlformats.org/drawingml/2006/main">
+              <a:ext uri="{FF2B5EF4-FFF2-40B4-BE49-F238E27FC236}">
+                <a16:creationId xmlns:a16="http://schemas.microsoft.com/office/drawing/2014/main" id="{C3B10C6A-E59F-4187-A6D6-6A05FE851838}"/>
+              </a:ext>
+            </a:extLst>
+          </p:cNvPr>
+          <p:cNvSpPr>
+            <a:spLocks xmlns:a="http://schemas.openxmlformats.org/drawingml/2006/main" noGrp="1"/>
+          </p:cNvSpPr>
+          <p:nvPr/>
+        </p:nvSpPr>
+        <p:spPr>
+          <a:xfrm xmlns:a="http://schemas.openxmlformats.org/drawingml/2006/main">
+            <a:off x="6848475" y="3048000"/>
+            <a:ext cx="1771650" cy="2286000"/>
+          </a:xfrm>
+          <a:prstGeom xmlns:a="http://schemas.openxmlformats.org/drawingml/2006/main" prst="roundRect">
+            <a:avLst>
+              <a:gd name="adj" fmla="val 6452"/>
+            </a:avLst>
+          </a:prstGeom>
+          <a:noFill xmlns:a="http://schemas.openxmlformats.org/drawingml/2006/main"/>
+          <a:ln xmlns:a="http://schemas.openxmlformats.org/drawingml/2006/main" w="19050">
+            <a:solidFill>
+              <a:srgbClr val="F07D00"/>
+            </a:solidFill>
+            <a:prstDash val="solid"/>
+          </a:ln>
+        </p:spPr>
+      </p:sp>
+      <p:sp>
+        <p:nvSpPr>
+          <p:cNvPr id="49" name="trace-stage-4-step">
+            <a:extLst xmlns:a="http://schemas.openxmlformats.org/drawingml/2006/main">
+              <a:ext uri="{FF2B5EF4-FFF2-40B4-BE49-F238E27FC236}">
+                <a16:creationId xmlns:a16="http://schemas.microsoft.com/office/drawing/2014/main" id="{8BF90EA8-2443-4E4C-B53A-B022E697EBFE}"/>
+              </a:ext>
+            </a:extLst>
+          </p:cNvPr>
+          <p:cNvSpPr>
+            <a:spLocks xmlns:a="http://schemas.openxmlformats.org/drawingml/2006/main" noGrp="1"/>
+          </p:cNvSpPr>
+          <p:nvPr/>
+        </p:nvSpPr>
+        <p:spPr>
+          <a:xfrm xmlns:a="http://schemas.openxmlformats.org/drawingml/2006/main">
+            <a:off x="7019925" y="3238500"/>
+            <a:ext cx="533400" cy="285750"/>
+          </a:xfrm>
+          <a:prstGeom xmlns:a="http://schemas.openxmlformats.org/drawingml/2006/main" prst="rect">
+            <a:avLst/>
+          </a:prstGeom>
+          <a:noFill xmlns:a="http://schemas.openxmlformats.org/drawingml/2006/main"/>
+          <a:ln xmlns:a="http://schemas.openxmlformats.org/drawingml/2006/main" w="0">
+            <a:noFill/>
+            <a:prstDash val="solid"/>
+          </a:ln>
+        </p:spPr>
+        <p:txBody>
+          <a:bodyPr xmlns:a="http://schemas.openxmlformats.org/drawingml/2006/main"/>
+          <a:lstStyle xmlns:a="http://schemas.openxmlformats.org/drawingml/2006/main"/>
+          <a:p xmlns:a="http://schemas.openxmlformats.org/drawingml/2006/main">
+            <a:pPr>
+              <a:defRPr sz="1500" b="1">
+                <a:solidFill>
+                  <a:srgbClr val="00A2EB"/>
+                </a:solidFill>
+              </a:defRPr>
+            </a:pPr>
+            <a:r>
+              <a:rPr sz="1500" b="1">
+                <a:solidFill>
+                  <a:srgbClr val="00A2EB"/>
+                </a:solidFill>
+              </a:rPr>
+              <a:t>04</a:t>
+            </a:r>
+          </a:p>
+        </p:txBody>
+      </p:sp>
+      <p:sp>
+        <p:nvSpPr>
+          <p:cNvPr id="50" name="trace-stage-4-title">
+            <a:extLst xmlns:a="http://schemas.openxmlformats.org/drawingml/2006/main">
+              <a:ext uri="{FF2B5EF4-FFF2-40B4-BE49-F238E27FC236}">
+                <a16:creationId xmlns:a16="http://schemas.microsoft.com/office/drawing/2014/main" id="{20E81F41-414E-46F1-9017-282A4CDFF8DF}"/>
+              </a:ext>
+            </a:extLst>
+          </p:cNvPr>
+          <p:cNvSpPr>
+            <a:spLocks xmlns:a="http://schemas.openxmlformats.org/drawingml/2006/main" noGrp="1"/>
+          </p:cNvSpPr>
+          <p:nvPr/>
+        </p:nvSpPr>
+        <p:spPr>
+          <a:xfrm xmlns:a="http://schemas.openxmlformats.org/drawingml/2006/main">
+            <a:off x="6962775" y="3733800"/>
+            <a:ext cx="1543050" cy="590550"/>
+          </a:xfrm>
+          <a:prstGeom xmlns:a="http://schemas.openxmlformats.org/drawingml/2006/main" prst="rect">
+            <a:avLst/>
+          </a:prstGeom>
+          <a:noFill xmlns:a="http://schemas.openxmlformats.org/drawingml/2006/main"/>
+          <a:ln xmlns:a="http://schemas.openxmlformats.org/drawingml/2006/main" w="0">
+            <a:noFill/>
+            <a:prstDash val="solid"/>
+          </a:ln>
+        </p:spPr>
+        <p:txBody>
+          <a:bodyPr xmlns:a="http://schemas.openxmlformats.org/drawingml/2006/main"/>
+          <a:lstStyle xmlns:a="http://schemas.openxmlformats.org/drawingml/2006/main"/>
+          <a:p xmlns:a="http://schemas.openxmlformats.org/drawingml/2006/main">
+            <a:pPr algn="ctr">
+              <a:defRPr sz="1575" b="1">
+                <a:solidFill>
+                  <a:srgbClr val="F07D00"/>
+                </a:solidFill>
+              </a:defRPr>
+            </a:pPr>
+            <a:r>
+              <a:rPr sz="1575" b="1">
+                <a:solidFill>
+                  <a:srgbClr val="F07D00"/>
+                </a:solidFill>
+              </a:rPr>
+              <a:t>REPLAN</a:t>
+            </a:r>
+          </a:p>
+        </p:txBody>
+      </p:sp>
+      <p:sp>
+        <p:nvSpPr>
+          <p:cNvPr id="51" name="trace-stage-4-body">
+            <a:extLst xmlns:a="http://schemas.openxmlformats.org/drawingml/2006/main">
+              <a:ext uri="{FF2B5EF4-FFF2-40B4-BE49-F238E27FC236}">
+                <a16:creationId xmlns:a16="http://schemas.microsoft.com/office/drawing/2014/main" id="{531F0166-3794-4A33-BF4C-0500EE6B1413}"/>
+              </a:ext>
+            </a:extLst>
+          </p:cNvPr>
+          <p:cNvSpPr>
+            <a:spLocks xmlns:a="http://schemas.openxmlformats.org/drawingml/2006/main" noGrp="1"/>
+          </p:cNvSpPr>
+          <p:nvPr/>
+        </p:nvSpPr>
+        <p:spPr>
+          <a:xfrm xmlns:a="http://schemas.openxmlformats.org/drawingml/2006/main">
+            <a:off x="6886575" y="4533900"/>
+            <a:ext cx="1695450" cy="552450"/>
+          </a:xfrm>
+          <a:prstGeom xmlns:a="http://schemas.openxmlformats.org/drawingml/2006/main" prst="rect">
+            <a:avLst/>
+          </a:prstGeom>
+          <a:noFill xmlns:a="http://schemas.openxmlformats.org/drawingml/2006/main"/>
+          <a:ln xmlns:a="http://schemas.openxmlformats.org/drawingml/2006/main" w="0">
+            <a:noFill/>
+            <a:prstDash val="solid"/>
+          </a:ln>
+        </p:spPr>
+        <p:txBody>
+          <a:bodyPr xmlns:a="http://schemas.openxmlformats.org/drawingml/2006/main"/>
+          <a:lstStyle xmlns:a="http://schemas.openxmlformats.org/drawingml/2006/main"/>
+          <a:p xmlns:a="http://schemas.openxmlformats.org/drawingml/2006/main">
+            <a:pPr algn="ctr">
+              <a:defRPr sz="1200" b="0">
+                <a:solidFill>
+                  <a:srgbClr val="F07D00"/>
+                </a:solidFill>
+              </a:defRPr>
+            </a:pPr>
+            <a:r>
+              <a:rPr sz="1200" b="0">
+                <a:solidFill>
+                  <a:srgbClr val="F07D00"/>
+                </a:solidFill>
+              </a:rPr>
+              <a:t>revision 1</a:t>
+            </a:r>
+          </a:p>
+          <a:p xmlns:a="http://schemas.openxmlformats.org/drawingml/2006/main">
+            <a:pPr algn="ctr">
+              <a:defRPr sz="1200" b="0">
+                <a:solidFill>
+                  <a:srgbClr val="F07D00"/>
+                </a:solidFill>
+              </a:defRPr>
+            </a:pPr>
+            <a:r>
+              <a:rPr sz="1200" b="0">
+                <a:solidFill>
+                  <a:srgbClr val="F07D00"/>
+                </a:solidFill>
+              </a:rPr>
+              <a:t>bounded recovery</a:t>
+            </a:r>
+          </a:p>
+        </p:txBody>
+      </p:sp>
+      <p:sp>
+        <p:nvSpPr>
+          <p:cNvPr id="52" name="trace-stage-5">
+            <a:extLst xmlns:a="http://schemas.openxmlformats.org/drawingml/2006/main">
+              <a:ext uri="{FF2B5EF4-FFF2-40B4-BE49-F238E27FC236}">
+                <a16:creationId xmlns:a16="http://schemas.microsoft.com/office/drawing/2014/main" id="{A66F224A-79FC-4433-8EE4-B0B6F50595F9}"/>
+              </a:ext>
+            </a:extLst>
+          </p:cNvPr>
+          <p:cNvSpPr>
+            <a:spLocks xmlns:a="http://schemas.openxmlformats.org/drawingml/2006/main" noGrp="1"/>
+          </p:cNvSpPr>
+          <p:nvPr/>
+        </p:nvSpPr>
+        <p:spPr>
+          <a:xfrm xmlns:a="http://schemas.openxmlformats.org/drawingml/2006/main">
+            <a:off x="8801100" y="3048000"/>
+            <a:ext cx="1771650" cy="2286000"/>
+          </a:xfrm>
+          <a:prstGeom xmlns:a="http://schemas.openxmlformats.org/drawingml/2006/main" prst="roundRect">
+            <a:avLst>
+              <a:gd name="adj" fmla="val 6452"/>
+            </a:avLst>
+          </a:prstGeom>
+          <a:noFill xmlns:a="http://schemas.openxmlformats.org/drawingml/2006/main"/>
+          <a:ln xmlns:a="http://schemas.openxmlformats.org/drawingml/2006/main" w="19050">
+            <a:solidFill>
+              <a:srgbClr val="2E8B57"/>
+            </a:solidFill>
+            <a:prstDash val="solid"/>
+          </a:ln>
+        </p:spPr>
+      </p:sp>
+      <p:sp>
+        <p:nvSpPr>
+          <p:cNvPr id="53" name="trace-stage-5-step">
+            <a:extLst xmlns:a="http://schemas.openxmlformats.org/drawingml/2006/main">
+              <a:ext uri="{FF2B5EF4-FFF2-40B4-BE49-F238E27FC236}">
+                <a16:creationId xmlns:a16="http://schemas.microsoft.com/office/drawing/2014/main" id="{4DA94BE3-B8A6-4A10-A2F0-A3EBFAD6D738}"/>
+              </a:ext>
+            </a:extLst>
+          </p:cNvPr>
+          <p:cNvSpPr>
+            <a:spLocks xmlns:a="http://schemas.openxmlformats.org/drawingml/2006/main" noGrp="1"/>
+          </p:cNvSpPr>
+          <p:nvPr/>
+        </p:nvSpPr>
+        <p:spPr>
+          <a:xfrm xmlns:a="http://schemas.openxmlformats.org/drawingml/2006/main">
+            <a:off x="8972550" y="3238500"/>
+            <a:ext cx="533400" cy="285750"/>
+          </a:xfrm>
+          <a:prstGeom xmlns:a="http://schemas.openxmlformats.org/drawingml/2006/main" prst="rect">
+            <a:avLst/>
+          </a:prstGeom>
+          <a:noFill xmlns:a="http://schemas.openxmlformats.org/drawingml/2006/main"/>
+          <a:ln xmlns:a="http://schemas.openxmlformats.org/drawingml/2006/main" w="0">
+            <a:noFill/>
+            <a:prstDash val="solid"/>
+          </a:ln>
+        </p:spPr>
+        <p:txBody>
+          <a:bodyPr xmlns:a="http://schemas.openxmlformats.org/drawingml/2006/main"/>
+          <a:lstStyle xmlns:a="http://schemas.openxmlformats.org/drawingml/2006/main"/>
+          <a:p xmlns:a="http://schemas.openxmlformats.org/drawingml/2006/main">
+            <a:pPr>
+              <a:defRPr sz="1500" b="1">
+                <a:solidFill>
+                  <a:srgbClr val="00A2EB"/>
+                </a:solidFill>
+              </a:defRPr>
+            </a:pPr>
+            <a:r>
+              <a:rPr sz="1500" b="1">
+                <a:solidFill>
+                  <a:srgbClr val="00A2EB"/>
+                </a:solidFill>
+              </a:rPr>
+              <a:t>05</a:t>
+            </a:r>
+          </a:p>
+        </p:txBody>
+      </p:sp>
+      <p:sp>
+        <p:nvSpPr>
+          <p:cNvPr id="54" name="trace-stage-5-title">
+            <a:extLst xmlns:a="http://schemas.openxmlformats.org/drawingml/2006/main">
+              <a:ext uri="{FF2B5EF4-FFF2-40B4-BE49-F238E27FC236}">
+                <a16:creationId xmlns:a16="http://schemas.microsoft.com/office/drawing/2014/main" id="{3EAA3FDE-42E0-4587-80FC-4DC6EE8A6310}"/>
+              </a:ext>
+            </a:extLst>
+          </p:cNvPr>
+          <p:cNvSpPr>
+            <a:spLocks xmlns:a="http://schemas.openxmlformats.org/drawingml/2006/main" noGrp="1"/>
+          </p:cNvSpPr>
+          <p:nvPr/>
+        </p:nvSpPr>
+        <p:spPr>
+          <a:xfrm xmlns:a="http://schemas.openxmlformats.org/drawingml/2006/main">
+            <a:off x="8915400" y="3733800"/>
+            <a:ext cx="1543050" cy="590550"/>
+          </a:xfrm>
+          <a:prstGeom xmlns:a="http://schemas.openxmlformats.org/drawingml/2006/main" prst="rect">
+            <a:avLst/>
+          </a:prstGeom>
+          <a:noFill xmlns:a="http://schemas.openxmlformats.org/drawingml/2006/main"/>
+          <a:ln xmlns:a="http://schemas.openxmlformats.org/drawingml/2006/main" w="0">
+            <a:noFill/>
+            <a:prstDash val="solid"/>
+          </a:ln>
+        </p:spPr>
+        <p:txBody>
+          <a:bodyPr xmlns:a="http://schemas.openxmlformats.org/drawingml/2006/main"/>
+          <a:lstStyle xmlns:a="http://schemas.openxmlformats.org/drawingml/2006/main"/>
+          <a:p xmlns:a="http://schemas.openxmlformats.org/drawingml/2006/main">
+            <a:pPr algn="ctr">
+              <a:defRPr sz="1575" b="1">
+                <a:solidFill>
+                  <a:srgbClr val="2E8B57"/>
+                </a:solidFill>
+              </a:defRPr>
+            </a:pPr>
+            <a:r>
+              <a:rPr sz="1575" b="1">
+                <a:solidFill>
+                  <a:srgbClr val="2E8B57"/>
+                </a:solidFill>
+              </a:rPr>
+              <a:t>TOOL</a:t>
+            </a:r>
+          </a:p>
+          <a:p xmlns:a="http://schemas.openxmlformats.org/drawingml/2006/main">
+            <a:pPr algn="ctr">
+              <a:defRPr sz="1575" b="1">
+                <a:solidFill>
+                  <a:srgbClr val="2E8B57"/>
+                </a:solidFill>
+              </a:defRPr>
+            </a:pPr>
+            <a:r>
+              <a:rPr sz="1575" b="1">
+                <a:solidFill>
+                  <a:srgbClr val="2E8B57"/>
+                </a:solidFill>
+              </a:rPr>
+              <a:t>ATTEMPTS</a:t>
+            </a:r>
+          </a:p>
+        </p:txBody>
+      </p:sp>
+      <p:sp>
+        <p:nvSpPr>
+          <p:cNvPr id="55" name="trace-stage-5-body">
+            <a:extLst xmlns:a="http://schemas.openxmlformats.org/drawingml/2006/main">
+              <a:ext uri="{FF2B5EF4-FFF2-40B4-BE49-F238E27FC236}">
+                <a16:creationId xmlns:a16="http://schemas.microsoft.com/office/drawing/2014/main" id="{39A5C400-4A30-4B6E-AF84-568ECB1189D0}"/>
+              </a:ext>
+            </a:extLst>
+          </p:cNvPr>
+          <p:cNvSpPr>
+            <a:spLocks xmlns:a="http://schemas.openxmlformats.org/drawingml/2006/main" noGrp="1"/>
+          </p:cNvSpPr>
+          <p:nvPr/>
+        </p:nvSpPr>
+        <p:spPr>
+          <a:xfrm xmlns:a="http://schemas.openxmlformats.org/drawingml/2006/main">
+            <a:off x="8839200" y="4533900"/>
+            <a:ext cx="1695450" cy="552450"/>
+          </a:xfrm>
+          <a:prstGeom xmlns:a="http://schemas.openxmlformats.org/drawingml/2006/main" prst="rect">
+            <a:avLst/>
+          </a:prstGeom>
+          <a:noFill xmlns:a="http://schemas.openxmlformats.org/drawingml/2006/main"/>
+          <a:ln xmlns:a="http://schemas.openxmlformats.org/drawingml/2006/main" w="0">
+            <a:noFill/>
+            <a:prstDash val="solid"/>
+          </a:ln>
+        </p:spPr>
+        <p:txBody>
+          <a:bodyPr xmlns:a="http://schemas.openxmlformats.org/drawingml/2006/main"/>
+          <a:lstStyle xmlns:a="http://schemas.openxmlformats.org/drawingml/2006/main"/>
+          <a:p xmlns:a="http://schemas.openxmlformats.org/drawingml/2006/main">
+            <a:pPr algn="ctr">
+              <a:defRPr sz="1200" b="0">
+                <a:solidFill>
+                  <a:srgbClr val="2E8B57"/>
+                </a:solidFill>
+              </a:defRPr>
+            </a:pPr>
+            <a:r>
+              <a:rPr sz="1200" b="0">
+                <a:solidFill>
+                  <a:srgbClr val="2E8B57"/>
+                </a:solidFill>
+              </a:rPr>
+              <a:t>attempts 4-5</a:t>
+            </a:r>
+          </a:p>
+          <a:p xmlns:a="http://schemas.openxmlformats.org/drawingml/2006/main">
+            <a:pPr algn="ctr">
+              <a:defRPr sz="1200" b="0">
+                <a:solidFill>
+                  <a:srgbClr val="2E8B57"/>
+                </a:solidFill>
+              </a:defRPr>
+            </a:pPr>
+            <a:r>
+              <a:rPr sz="1200" b="0">
+                <a:solidFill>
+                  <a:srgbClr val="2E8B57"/>
+                </a:solidFill>
+              </a:rPr>
+              <a:t>post-error success</a:t>
+            </a:r>
+          </a:p>
+        </p:txBody>
+      </p:sp>
+      <p:sp>
+        <p:nvSpPr>
+          <p:cNvPr id="56" name="trace-stage-6">
+            <a:extLst xmlns:a="http://schemas.openxmlformats.org/drawingml/2006/main">
+              <a:ext uri="{FF2B5EF4-FFF2-40B4-BE49-F238E27FC236}">
+                <a16:creationId xmlns:a16="http://schemas.microsoft.com/office/drawing/2014/main" id="{B297F765-A263-4428-8584-AF2E5E9D86C2}"/>
+              </a:ext>
+            </a:extLst>
+          </p:cNvPr>
+          <p:cNvSpPr>
+            <a:spLocks xmlns:a="http://schemas.openxmlformats.org/drawingml/2006/main" noGrp="1"/>
+          </p:cNvSpPr>
+          <p:nvPr/>
+        </p:nvSpPr>
+        <p:spPr>
+          <a:xfrm xmlns:a="http://schemas.openxmlformats.org/drawingml/2006/main">
+            <a:off x="10753725" y="3048000"/>
+            <a:ext cx="1771650" cy="2286000"/>
+          </a:xfrm>
+          <a:prstGeom xmlns:a="http://schemas.openxmlformats.org/drawingml/2006/main" prst="roundRect">
+            <a:avLst>
+              <a:gd name="adj" fmla="val 6452"/>
+            </a:avLst>
+          </a:prstGeom>
+          <a:noFill xmlns:a="http://schemas.openxmlformats.org/drawingml/2006/main"/>
+          <a:ln xmlns:a="http://schemas.openxmlformats.org/drawingml/2006/main" w="19050">
+            <a:solidFill>
+              <a:srgbClr val="00A2EB"/>
+            </a:solidFill>
+            <a:prstDash val="solid"/>
+          </a:ln>
+        </p:spPr>
+      </p:sp>
+      <p:sp>
+        <p:nvSpPr>
+          <p:cNvPr id="57" name="trace-stage-6-step">
+            <a:extLst xmlns:a="http://schemas.openxmlformats.org/drawingml/2006/main">
+              <a:ext uri="{FF2B5EF4-FFF2-40B4-BE49-F238E27FC236}">
+                <a16:creationId xmlns:a16="http://schemas.microsoft.com/office/drawing/2014/main" id="{65F3307D-E778-4B53-B738-B05D39356852}"/>
+              </a:ext>
+            </a:extLst>
+          </p:cNvPr>
+          <p:cNvSpPr>
+            <a:spLocks xmlns:a="http://schemas.openxmlformats.org/drawingml/2006/main" noGrp="1"/>
+          </p:cNvSpPr>
+          <p:nvPr/>
+        </p:nvSpPr>
+        <p:spPr>
+          <a:xfrm xmlns:a="http://schemas.openxmlformats.org/drawingml/2006/main">
+            <a:off x="10925175" y="3238500"/>
+            <a:ext cx="533400" cy="285750"/>
+          </a:xfrm>
+          <a:prstGeom xmlns:a="http://schemas.openxmlformats.org/drawingml/2006/main" prst="rect">
+            <a:avLst/>
+          </a:prstGeom>
+          <a:noFill xmlns:a="http://schemas.openxmlformats.org/drawingml/2006/main"/>
+          <a:ln xmlns:a="http://schemas.openxmlformats.org/drawingml/2006/main" w="0">
+            <a:noFill/>
+            <a:prstDash val="solid"/>
+          </a:ln>
+        </p:spPr>
+        <p:txBody>
+          <a:bodyPr xmlns:a="http://schemas.openxmlformats.org/drawingml/2006/main"/>
+          <a:lstStyle xmlns:a="http://schemas.openxmlformats.org/drawingml/2006/main"/>
+          <a:p xmlns:a="http://schemas.openxmlformats.org/drawingml/2006/main">
+            <a:pPr>
+              <a:defRPr sz="1500" b="1">
+                <a:solidFill>
+                  <a:srgbClr val="00A2EB"/>
+                </a:solidFill>
+              </a:defRPr>
+            </a:pPr>
+            <a:r>
+              <a:rPr sz="1500" b="1">
+                <a:solidFill>
+                  <a:srgbClr val="00A2EB"/>
+                </a:solidFill>
+              </a:rPr>
+              <a:t>06</a:t>
+            </a:r>
+          </a:p>
+        </p:txBody>
+      </p:sp>
+      <p:sp>
+        <p:nvSpPr>
+          <p:cNvPr id="58" name="trace-stage-6-title">
+            <a:extLst xmlns:a="http://schemas.openxmlformats.org/drawingml/2006/main">
+              <a:ext uri="{FF2B5EF4-FFF2-40B4-BE49-F238E27FC236}">
+                <a16:creationId xmlns:a16="http://schemas.microsoft.com/office/drawing/2014/main" id="{3BF74CAD-5A15-45AB-841B-C80336555CEB}"/>
+              </a:ext>
+            </a:extLst>
+          </p:cNvPr>
+          <p:cNvSpPr>
+            <a:spLocks xmlns:a="http://schemas.openxmlformats.org/drawingml/2006/main" noGrp="1"/>
+          </p:cNvSpPr>
+          <p:nvPr/>
+        </p:nvSpPr>
+        <p:spPr>
+          <a:xfrm xmlns:a="http://schemas.openxmlformats.org/drawingml/2006/main">
+            <a:off x="10868025" y="3733800"/>
+            <a:ext cx="1543050" cy="590550"/>
+          </a:xfrm>
+          <a:prstGeom xmlns:a="http://schemas.openxmlformats.org/drawingml/2006/main" prst="rect">
+            <a:avLst/>
+          </a:prstGeom>
+          <a:noFill xmlns:a="http://schemas.openxmlformats.org/drawingml/2006/main"/>
+          <a:ln xmlns:a="http://schemas.openxmlformats.org/drawingml/2006/main" w="0">
+            <a:noFill/>
+            <a:prstDash val="solid"/>
+          </a:ln>
+        </p:spPr>
+        <p:txBody>
+          <a:bodyPr xmlns:a="http://schemas.openxmlformats.org/drawingml/2006/main"/>
+          <a:lstStyle xmlns:a="http://schemas.openxmlformats.org/drawingml/2006/main"/>
+          <a:p xmlns:a="http://schemas.openxmlformats.org/drawingml/2006/main">
+            <a:pPr algn="ctr">
+              <a:defRPr sz="1575" b="1">
+                <a:solidFill>
+                  <a:srgbClr val="0A2030"/>
+                </a:solidFill>
+              </a:defRPr>
+            </a:pPr>
+            <a:r>
+              <a:rPr sz="1575" b="1">
+                <a:solidFill>
+                  <a:srgbClr val="0A2030"/>
+                </a:solidFill>
+              </a:rPr>
+              <a:t>EVIDENCE</a:t>
+            </a:r>
+          </a:p>
+          <a:p xmlns:a="http://schemas.openxmlformats.org/drawingml/2006/main">
+            <a:pPr algn="ctr">
+              <a:defRPr sz="1575" b="1">
+                <a:solidFill>
+                  <a:srgbClr val="0A2030"/>
+                </a:solidFill>
+              </a:defRPr>
+            </a:pPr>
+            <a:r>
+              <a:rPr sz="1575" b="1">
+                <a:solidFill>
+                  <a:srgbClr val="0A2030"/>
+                </a:solidFill>
+              </a:rPr>
+              <a:t>GATE</a:t>
+            </a:r>
+          </a:p>
+        </p:txBody>
+      </p:sp>
+      <p:sp>
+        <p:nvSpPr>
+          <p:cNvPr id="59" name="trace-stage-6-body">
+            <a:extLst xmlns:a="http://schemas.openxmlformats.org/drawingml/2006/main">
+              <a:ext uri="{FF2B5EF4-FFF2-40B4-BE49-F238E27FC236}">
+                <a16:creationId xmlns:a16="http://schemas.microsoft.com/office/drawing/2014/main" id="{412B9B49-9498-4CE7-8DBE-3D133DD25CA8}"/>
+              </a:ext>
+            </a:extLst>
+          </p:cNvPr>
+          <p:cNvSpPr>
+            <a:spLocks xmlns:a="http://schemas.openxmlformats.org/drawingml/2006/main" noGrp="1"/>
+          </p:cNvSpPr>
+          <p:nvPr/>
+        </p:nvSpPr>
+        <p:spPr>
+          <a:xfrm xmlns:a="http://schemas.openxmlformats.org/drawingml/2006/main">
+            <a:off x="10791825" y="4533900"/>
+            <a:ext cx="1695450" cy="552450"/>
+          </a:xfrm>
+          <a:prstGeom xmlns:a="http://schemas.openxmlformats.org/drawingml/2006/main" prst="rect">
+            <a:avLst/>
+          </a:prstGeom>
+          <a:noFill xmlns:a="http://schemas.openxmlformats.org/drawingml/2006/main"/>
+          <a:ln xmlns:a="http://schemas.openxmlformats.org/drawingml/2006/main" w="0">
+            <a:noFill/>
+            <a:prstDash val="solid"/>
+          </a:ln>
+        </p:spPr>
+        <p:txBody>
+          <a:bodyPr xmlns:a="http://schemas.openxmlformats.org/drawingml/2006/main"/>
+          <a:lstStyle xmlns:a="http://schemas.openxmlformats.org/drawingml/2006/main"/>
+          <a:p xmlns:a="http://schemas.openxmlformats.org/drawingml/2006/main">
+            <a:pPr algn="ctr">
+              <a:defRPr sz="1200" b="0">
+                <a:solidFill>
+                  <a:srgbClr val="1F40CB"/>
+                </a:solidFill>
+              </a:defRPr>
+            </a:pPr>
+            <a:r>
+              <a:rPr sz="1200" b="0">
+                <a:solidFill>
+                  <a:srgbClr val="1F40CB"/>
+                </a:solidFill>
+              </a:rPr>
+              <a:t>source +</a:t>
+            </a:r>
+          </a:p>
+          <a:p xmlns:a="http://schemas.openxmlformats.org/drawingml/2006/main">
+            <a:pPr algn="ctr">
+              <a:defRPr sz="1200" b="0">
+                <a:solidFill>
+                  <a:srgbClr val="1F40CB"/>
+                </a:solidFill>
+              </a:defRPr>
+            </a:pPr>
+            <a:r>
+              <a:rPr sz="1200" b="0">
+                <a:solidFill>
+                  <a:srgbClr val="1F40CB"/>
+                </a:solidFill>
+              </a:rPr>
+              <a:t>evidence pairs</a:t>
+            </a:r>
+          </a:p>
+        </p:txBody>
+      </p:sp>
+      <p:sp>
+        <p:nvSpPr>
+          <p:cNvPr id="60" name="trace-stage-7">
+            <a:extLst xmlns:a="http://schemas.openxmlformats.org/drawingml/2006/main">
+              <a:ext uri="{FF2B5EF4-FFF2-40B4-BE49-F238E27FC236}">
+                <a16:creationId xmlns:a16="http://schemas.microsoft.com/office/drawing/2014/main" id="{487E1049-C402-43E7-8FAA-D5C8D8652380}"/>
+              </a:ext>
+            </a:extLst>
+          </p:cNvPr>
+          <p:cNvSpPr>
+            <a:spLocks xmlns:a="http://schemas.openxmlformats.org/drawingml/2006/main" noGrp="1"/>
+          </p:cNvSpPr>
+          <p:nvPr/>
+        </p:nvSpPr>
+        <p:spPr>
+          <a:xfrm xmlns:a="http://schemas.openxmlformats.org/drawingml/2006/main">
+            <a:off x="12706350" y="3048000"/>
+            <a:ext cx="1771650" cy="2286000"/>
+          </a:xfrm>
+          <a:prstGeom xmlns:a="http://schemas.openxmlformats.org/drawingml/2006/main" prst="roundRect">
+            <a:avLst>
+              <a:gd name="adj" fmla="val 6452"/>
+            </a:avLst>
+          </a:prstGeom>
+          <a:noFill xmlns:a="http://schemas.openxmlformats.org/drawingml/2006/main"/>
+          <a:ln xmlns:a="http://schemas.openxmlformats.org/drawingml/2006/main" w="19050">
+            <a:solidFill>
+              <a:srgbClr val="F07D00"/>
+            </a:solidFill>
+            <a:prstDash val="solid"/>
+          </a:ln>
+        </p:spPr>
+      </p:sp>
+      <p:sp>
+        <p:nvSpPr>
+          <p:cNvPr id="61" name="trace-stage-7-step">
+            <a:extLst xmlns:a="http://schemas.openxmlformats.org/drawingml/2006/main">
+              <a:ext uri="{FF2B5EF4-FFF2-40B4-BE49-F238E27FC236}">
+                <a16:creationId xmlns:a16="http://schemas.microsoft.com/office/drawing/2014/main" id="{D99BA43C-AC15-45F4-B8C4-2287BBF4ECAA}"/>
+              </a:ext>
+            </a:extLst>
+          </p:cNvPr>
+          <p:cNvSpPr>
+            <a:spLocks xmlns:a="http://schemas.openxmlformats.org/drawingml/2006/main" noGrp="1"/>
+          </p:cNvSpPr>
+          <p:nvPr/>
+        </p:nvSpPr>
+        <p:spPr>
+          <a:xfrm xmlns:a="http://schemas.openxmlformats.org/drawingml/2006/main">
+            <a:off x="12877800" y="3238500"/>
+            <a:ext cx="533400" cy="285750"/>
+          </a:xfrm>
+          <a:prstGeom xmlns:a="http://schemas.openxmlformats.org/drawingml/2006/main" prst="rect">
+            <a:avLst/>
+          </a:prstGeom>
+          <a:noFill xmlns:a="http://schemas.openxmlformats.org/drawingml/2006/main"/>
+          <a:ln xmlns:a="http://schemas.openxmlformats.org/drawingml/2006/main" w="0">
+            <a:noFill/>
+            <a:prstDash val="solid"/>
+          </a:ln>
+        </p:spPr>
+        <p:txBody>
+          <a:bodyPr xmlns:a="http://schemas.openxmlformats.org/drawingml/2006/main"/>
+          <a:lstStyle xmlns:a="http://schemas.openxmlformats.org/drawingml/2006/main"/>
+          <a:p xmlns:a="http://schemas.openxmlformats.org/drawingml/2006/main">
+            <a:pPr>
+              <a:defRPr sz="1500" b="1">
+                <a:solidFill>
+                  <a:srgbClr val="00A2EB"/>
+                </a:solidFill>
+              </a:defRPr>
+            </a:pPr>
+            <a:r>
+              <a:rPr sz="1500" b="1">
+                <a:solidFill>
+                  <a:srgbClr val="00A2EB"/>
+                </a:solidFill>
+              </a:rPr>
+              <a:t>07</a:t>
+            </a:r>
+          </a:p>
+        </p:txBody>
+      </p:sp>
+      <p:sp>
+        <p:nvSpPr>
+          <p:cNvPr id="62" name="trace-stage-7-title">
+            <a:extLst xmlns:a="http://schemas.openxmlformats.org/drawingml/2006/main">
+              <a:ext uri="{FF2B5EF4-FFF2-40B4-BE49-F238E27FC236}">
+                <a16:creationId xmlns:a16="http://schemas.microsoft.com/office/drawing/2014/main" id="{8BC7260B-022A-40C5-8C21-61EB65C48DC6}"/>
+              </a:ext>
+            </a:extLst>
+          </p:cNvPr>
+          <p:cNvSpPr>
+            <a:spLocks xmlns:a="http://schemas.openxmlformats.org/drawingml/2006/main" noGrp="1"/>
+          </p:cNvSpPr>
+          <p:nvPr/>
+        </p:nvSpPr>
+        <p:spPr>
+          <a:xfrm xmlns:a="http://schemas.openxmlformats.org/drawingml/2006/main">
+            <a:off x="12820650" y="3733800"/>
+            <a:ext cx="1543050" cy="590550"/>
+          </a:xfrm>
+          <a:prstGeom xmlns:a="http://schemas.openxmlformats.org/drawingml/2006/main" prst="rect">
+            <a:avLst/>
+          </a:prstGeom>
+          <a:noFill xmlns:a="http://schemas.openxmlformats.org/drawingml/2006/main"/>
+          <a:ln xmlns:a="http://schemas.openxmlformats.org/drawingml/2006/main" w="0">
+            <a:noFill/>
+            <a:prstDash val="solid"/>
+          </a:ln>
+        </p:spPr>
+        <p:txBody>
+          <a:bodyPr xmlns:a="http://schemas.openxmlformats.org/drawingml/2006/main"/>
+          <a:lstStyle xmlns:a="http://schemas.openxmlformats.org/drawingml/2006/main"/>
+          <a:p xmlns:a="http://schemas.openxmlformats.org/drawingml/2006/main">
+            <a:pPr algn="ctr">
+              <a:defRPr sz="1575" b="1">
+                <a:solidFill>
+                  <a:srgbClr val="0A2030"/>
+                </a:solidFill>
+              </a:defRPr>
+            </a:pPr>
+            <a:r>
+              <a:rPr sz="1575" b="1">
+                <a:solidFill>
+                  <a:srgbClr val="0A2030"/>
+                </a:solidFill>
+              </a:rPr>
+              <a:t>REPORT</a:t>
+            </a:r>
+          </a:p>
+        </p:txBody>
+      </p:sp>
+      <p:sp>
+        <p:nvSpPr>
+          <p:cNvPr id="63" name="trace-stage-7-body">
+            <a:extLst xmlns:a="http://schemas.openxmlformats.org/drawingml/2006/main">
+              <a:ext uri="{FF2B5EF4-FFF2-40B4-BE49-F238E27FC236}">
+                <a16:creationId xmlns:a16="http://schemas.microsoft.com/office/drawing/2014/main" id="{68E3277F-1E35-4D00-AB85-4AC545C9F5AD}"/>
+              </a:ext>
+            </a:extLst>
+          </p:cNvPr>
+          <p:cNvSpPr>
+            <a:spLocks xmlns:a="http://schemas.openxmlformats.org/drawingml/2006/main" noGrp="1"/>
+          </p:cNvSpPr>
+          <p:nvPr/>
+        </p:nvSpPr>
+        <p:spPr>
+          <a:xfrm xmlns:a="http://schemas.openxmlformats.org/drawingml/2006/main">
+            <a:off x="12744450" y="4533900"/>
+            <a:ext cx="1695450" cy="552450"/>
+          </a:xfrm>
+          <a:prstGeom xmlns:a="http://schemas.openxmlformats.org/drawingml/2006/main" prst="rect">
+            <a:avLst/>
+          </a:prstGeom>
+          <a:noFill xmlns:a="http://schemas.openxmlformats.org/drawingml/2006/main"/>
+          <a:ln xmlns:a="http://schemas.openxmlformats.org/drawingml/2006/main" w="0">
+            <a:noFill/>
+            <a:prstDash val="solid"/>
+          </a:ln>
+        </p:spPr>
+        <p:txBody>
+          <a:bodyPr xmlns:a="http://schemas.openxmlformats.org/drawingml/2006/main"/>
+          <a:lstStyle xmlns:a="http://schemas.openxmlformats.org/drawingml/2006/main"/>
+          <a:p xmlns:a="http://schemas.openxmlformats.org/drawingml/2006/main">
+            <a:pPr algn="ctr">
+              <a:defRPr sz="1200" b="0">
+                <a:solidFill>
+                  <a:srgbClr val="1F40CB"/>
+                </a:solidFill>
+              </a:defRPr>
+            </a:pPr>
+            <a:r>
+              <a:rPr sz="1200" b="0">
+                <a:solidFill>
+                  <a:srgbClr val="1F40CB"/>
+                </a:solidFill>
+              </a:rPr>
+              <a:t>briefing +</a:t>
+            </a:r>
+          </a:p>
+          <a:p xmlns:a="http://schemas.openxmlformats.org/drawingml/2006/main">
+            <a:pPr algn="ctr">
+              <a:defRPr sz="1200" b="0">
+                <a:solidFill>
+                  <a:srgbClr val="1F40CB"/>
+                </a:solidFill>
+              </a:defRPr>
+            </a:pPr>
+            <a:r>
+              <a:rPr sz="1200" b="0">
+                <a:solidFill>
+                  <a:srgbClr val="1F40CB"/>
+                </a:solidFill>
+              </a:rPr>
+              <a:t>citations</a:t>
+            </a:r>
+          </a:p>
+        </p:txBody>
+      </p:sp>
+      <p:cxnSp>
+        <p:nvCxnSpPr>
+          <p:cNvPr id="108" name=""/>
+          <p:cNvCxnSpPr>
+            <a:stCxn xmlns:a="http://schemas.openxmlformats.org/drawingml/2006/main" id="36" idx="3"/>
+            <a:endCxn xmlns:a="http://schemas.openxmlformats.org/drawingml/2006/main" id="40" idx="1"/>
+          </p:cNvCxnSpPr>
+          <p:nvPr/>
+        </p:nvCxnSpPr>
+        <p:spPr>
+          <a:xfrm xmlns:a="http://schemas.openxmlformats.org/drawingml/2006/main">
+            <a:off x="2762250" y="4191000"/>
+            <a:ext cx="180975" cy="0"/>
+          </a:xfrm>
+          <a:prstGeom xmlns:a="http://schemas.openxmlformats.org/drawingml/2006/main" prst="straightConnector1">
+            <a:avLst/>
+          </a:prstGeom>
+          <a:ln xmlns:a="http://schemas.openxmlformats.org/drawingml/2006/main" w="19050">
+            <a:solidFill>
+              <a:srgbClr val="9A9A9F"/>
+            </a:solidFill>
+            <a:prstDash val="solid"/>
+            <a:tailEnd type="triangle" w="sm" len="sm"/>
+          </a:ln>
+        </p:spPr>
+      </p:cxnSp>
+      <p:cxnSp>
+        <p:nvCxnSpPr>
+          <p:cNvPr id="109" name=""/>
+          <p:cNvCxnSpPr>
+            <a:stCxn xmlns:a="http://schemas.openxmlformats.org/drawingml/2006/main" id="40" idx="3"/>
+            <a:endCxn xmlns:a="http://schemas.openxmlformats.org/drawingml/2006/main" id="44" idx="1"/>
+          </p:cNvCxnSpPr>
+          <p:nvPr/>
+        </p:nvCxnSpPr>
+        <p:spPr>
+          <a:xfrm xmlns:a="http://schemas.openxmlformats.org/drawingml/2006/main">
+            <a:off x="4714875" y="4191000"/>
+            <a:ext cx="180975" cy="0"/>
+          </a:xfrm>
+          <a:prstGeom xmlns:a="http://schemas.openxmlformats.org/drawingml/2006/main" prst="straightConnector1">
+            <a:avLst/>
+          </a:prstGeom>
+          <a:ln xmlns:a="http://schemas.openxmlformats.org/drawingml/2006/main" w="19050">
+            <a:solidFill>
+              <a:srgbClr val="9A9A9F"/>
+            </a:solidFill>
+            <a:prstDash val="solid"/>
+            <a:tailEnd type="triangle" w="sm" len="sm"/>
+          </a:ln>
+        </p:spPr>
+      </p:cxnSp>
+      <p:cxnSp>
+        <p:nvCxnSpPr>
+          <p:cNvPr id="110" name=""/>
+          <p:cNvCxnSpPr>
+            <a:stCxn xmlns:a="http://schemas.openxmlformats.org/drawingml/2006/main" id="44" idx="3"/>
+            <a:endCxn xmlns:a="http://schemas.openxmlformats.org/drawingml/2006/main" id="48" idx="1"/>
+          </p:cNvCxnSpPr>
+          <p:nvPr/>
+        </p:nvCxnSpPr>
+        <p:spPr>
+          <a:xfrm xmlns:a="http://schemas.openxmlformats.org/drawingml/2006/main">
+            <a:off x="6667500" y="4191000"/>
+            <a:ext cx="180975" cy="0"/>
+          </a:xfrm>
+          <a:prstGeom xmlns:a="http://schemas.openxmlformats.org/drawingml/2006/main" prst="straightConnector1">
+            <a:avLst/>
+          </a:prstGeom>
+          <a:ln xmlns:a="http://schemas.openxmlformats.org/drawingml/2006/main" w="19050">
+            <a:solidFill>
+              <a:srgbClr val="9A9A9F"/>
+            </a:solidFill>
+            <a:prstDash val="solid"/>
+            <a:tailEnd type="triangle" w="sm" len="sm"/>
+          </a:ln>
+        </p:spPr>
+      </p:cxnSp>
+      <p:cxnSp>
+        <p:nvCxnSpPr>
+          <p:cNvPr id="111" name=""/>
+          <p:cNvCxnSpPr>
+            <a:stCxn xmlns:a="http://schemas.openxmlformats.org/drawingml/2006/main" id="48" idx="3"/>
+            <a:endCxn xmlns:a="http://schemas.openxmlformats.org/drawingml/2006/main" id="52" idx="1"/>
+          </p:cNvCxnSpPr>
+          <p:nvPr/>
+        </p:nvCxnSpPr>
+        <p:spPr>
+          <a:xfrm xmlns:a="http://schemas.openxmlformats.org/drawingml/2006/main">
+            <a:off x="8620125" y="4191000"/>
+            <a:ext cx="180975" cy="0"/>
+          </a:xfrm>
+          <a:prstGeom xmlns:a="http://schemas.openxmlformats.org/drawingml/2006/main" prst="straightConnector1">
+            <a:avLst/>
+          </a:prstGeom>
+          <a:ln xmlns:a="http://schemas.openxmlformats.org/drawingml/2006/main" w="19050">
+            <a:solidFill>
+              <a:srgbClr val="9A9A9F"/>
+            </a:solidFill>
+            <a:prstDash val="solid"/>
+            <a:tailEnd type="triangle" w="sm" len="sm"/>
+          </a:ln>
+        </p:spPr>
+      </p:cxnSp>
+      <p:cxnSp>
+        <p:nvCxnSpPr>
+          <p:cNvPr id="112" name=""/>
+          <p:cNvCxnSpPr>
+            <a:stCxn xmlns:a="http://schemas.openxmlformats.org/drawingml/2006/main" id="52" idx="3"/>
+            <a:endCxn xmlns:a="http://schemas.openxmlformats.org/drawingml/2006/main" id="56" idx="1"/>
+          </p:cNvCxnSpPr>
+          <p:nvPr/>
+        </p:nvCxnSpPr>
+        <p:spPr>
+          <a:xfrm xmlns:a="http://schemas.openxmlformats.org/drawingml/2006/main">
+            <a:off x="10572750" y="4191000"/>
+            <a:ext cx="180975" cy="0"/>
+          </a:xfrm>
+          <a:prstGeom xmlns:a="http://schemas.openxmlformats.org/drawingml/2006/main" prst="straightConnector1">
+            <a:avLst/>
+          </a:prstGeom>
+          <a:ln xmlns:a="http://schemas.openxmlformats.org/drawingml/2006/main" w="19050">
+            <a:solidFill>
+              <a:srgbClr val="9A9A9F"/>
+            </a:solidFill>
+            <a:prstDash val="solid"/>
+            <a:tailEnd type="triangle" w="sm" len="sm"/>
+          </a:ln>
+        </p:spPr>
+      </p:cxnSp>
+      <p:cxnSp>
+        <p:nvCxnSpPr>
+          <p:cNvPr id="113" name=""/>
+          <p:cNvCxnSpPr>
+            <a:stCxn xmlns:a="http://schemas.openxmlformats.org/drawingml/2006/main" id="56" idx="3"/>
+            <a:endCxn xmlns:a="http://schemas.openxmlformats.org/drawingml/2006/main" id="60" idx="1"/>
+          </p:cNvCxnSpPr>
+          <p:nvPr/>
+        </p:nvCxnSpPr>
+        <p:spPr>
+          <a:xfrm xmlns:a="http://schemas.openxmlformats.org/drawingml/2006/main">
+            <a:off x="12525375" y="4191000"/>
+            <a:ext cx="180975" cy="0"/>
+          </a:xfrm>
+          <a:prstGeom xmlns:a="http://schemas.openxmlformats.org/drawingml/2006/main" prst="straightConnector1">
+            <a:avLst/>
+          </a:prstGeom>
+          <a:ln xmlns:a="http://schemas.openxmlformats.org/drawingml/2006/main" w="19050">
+            <a:solidFill>
+              <a:srgbClr val="9A9A9F"/>
+            </a:solidFill>
+            <a:prstDash val="solid"/>
+            <a:tailEnd type="triangle" w="sm" len="sm"/>
+          </a:ln>
+        </p:spPr>
+      </p:cxnSp>
     </p:spTree>
     <p:extLst>
       <p:ext uri="{BB962C8B-B14F-4D97-AF65-F5344CB8AC3E}">

</xml_diff>